<commit_message>
[CI] Publish Documentation for 59a0c4e8006d1cace65c749f770e4b420d1a461d
</commit_message>
<xml_diff>
--- a/espd-wgm/_attachments/ESPD_OUC_Meetings_Slides_20260611.pptx
+++ b/espd-wgm/_attachments/ESPD_OUC_Meetings_Slides_20260611.pptx
@@ -217,6 +217,641 @@
 <file path=ppt/changesInfos/changesInfo1.xml><?xml version="1.0" encoding="utf-8"?>
 <pc:chgInfo xmlns:a="http://schemas.openxmlformats.org/drawingml/2006/main" xmlns:r="http://schemas.openxmlformats.org/officeDocument/2006/relationships" xmlns:ac="http://schemas.microsoft.com/office/drawing/2013/main/command" xmlns:pc="http://schemas.microsoft.com/office/powerpoint/2013/main/command">
   <pc:docChgLst>
+    <pc:chgData name="KRASIC Srdjan (OP-EXT)" userId="S::srdjan.krasic@ext.ec.europa.eu::6da91b18-32dc-43bc-a9cc-2ff6f82cb0e8" providerId="AD" clId="Web-{D70C1FEB-295E-8F8B-383E-4E4563ABA334}"/>
+    <pc:docChg chg="modSld">
+      <pc:chgData name="KRASIC Srdjan (OP-EXT)" userId="S::srdjan.krasic@ext.ec.europa.eu::6da91b18-32dc-43bc-a9cc-2ff6f82cb0e8" providerId="AD" clId="Web-{D70C1FEB-295E-8F8B-383E-4E4563ABA334}" dt="2026-06-09T13:10:35.813" v="6" actId="20577"/>
+      <pc:docMkLst>
+        <pc:docMk/>
+      </pc:docMkLst>
+      <pc:sldChg chg="modSp">
+        <pc:chgData name="KRASIC Srdjan (OP-EXT)" userId="S::srdjan.krasic@ext.ec.europa.eu::6da91b18-32dc-43bc-a9cc-2ff6f82cb0e8" providerId="AD" clId="Web-{D70C1FEB-295E-8F8B-383E-4E4563ABA334}" dt="2026-06-09T13:10:35.813" v="6" actId="20577"/>
+        <pc:sldMkLst>
+          <pc:docMk/>
+          <pc:sldMk cId="3777327881" sldId="259"/>
+        </pc:sldMkLst>
+        <pc:spChg chg="mod">
+          <ac:chgData name="KRASIC Srdjan (OP-EXT)" userId="S::srdjan.krasic@ext.ec.europa.eu::6da91b18-32dc-43bc-a9cc-2ff6f82cb0e8" providerId="AD" clId="Web-{D70C1FEB-295E-8F8B-383E-4E4563ABA334}" dt="2026-06-09T13:10:35.813" v="6" actId="20577"/>
+          <ac:spMkLst>
+            <pc:docMk/>
+            <pc:sldMk cId="3777327881" sldId="259"/>
+            <ac:spMk id="18" creationId="{37F7CF56-95DD-32F5-E7F0-77DDD56B57E1}"/>
+          </ac:spMkLst>
+        </pc:spChg>
+      </pc:sldChg>
+    </pc:docChg>
+  </pc:docChgLst>
+  <pc:docChgLst>
+    <pc:chgData name="KRASIC Srdjan (OP-EXT)" userId="S::srdjan.krasic@ext.ec.europa.eu::6da91b18-32dc-43bc-a9cc-2ff6f82cb0e8" providerId="AD" clId="Web-{EF396895-D3C6-4FE9-CA0B-9A5304DD48B9}"/>
+    <pc:docChg chg="modSld">
+      <pc:chgData name="KRASIC Srdjan (OP-EXT)" userId="S::srdjan.krasic@ext.ec.europa.eu::6da91b18-32dc-43bc-a9cc-2ff6f82cb0e8" providerId="AD" clId="Web-{EF396895-D3C6-4FE9-CA0B-9A5304DD48B9}" dt="2026-06-08T19:48:36.569" v="4" actId="20577"/>
+      <pc:docMkLst>
+        <pc:docMk/>
+      </pc:docMkLst>
+      <pc:sldChg chg="modSp">
+        <pc:chgData name="KRASIC Srdjan (OP-EXT)" userId="S::srdjan.krasic@ext.ec.europa.eu::6da91b18-32dc-43bc-a9cc-2ff6f82cb0e8" providerId="AD" clId="Web-{EF396895-D3C6-4FE9-CA0B-9A5304DD48B9}" dt="2026-06-08T19:47:55.019" v="0" actId="20577"/>
+        <pc:sldMkLst>
+          <pc:docMk/>
+          <pc:sldMk cId="2699462789" sldId="1417"/>
+        </pc:sldMkLst>
+        <pc:spChg chg="mod">
+          <ac:chgData name="KRASIC Srdjan (OP-EXT)" userId="S::srdjan.krasic@ext.ec.europa.eu::6da91b18-32dc-43bc-a9cc-2ff6f82cb0e8" providerId="AD" clId="Web-{EF396895-D3C6-4FE9-CA0B-9A5304DD48B9}" dt="2026-06-08T19:47:55.019" v="0" actId="20577"/>
+          <ac:spMkLst>
+            <pc:docMk/>
+            <pc:sldMk cId="2699462789" sldId="1417"/>
+            <ac:spMk id="2" creationId="{E50ADB50-3F58-336E-5BC6-335254A8877D}"/>
+          </ac:spMkLst>
+        </pc:spChg>
+      </pc:sldChg>
+      <pc:sldChg chg="modSp">
+        <pc:chgData name="KRASIC Srdjan (OP-EXT)" userId="S::srdjan.krasic@ext.ec.europa.eu::6da91b18-32dc-43bc-a9cc-2ff6f82cb0e8" providerId="AD" clId="Web-{EF396895-D3C6-4FE9-CA0B-9A5304DD48B9}" dt="2026-06-08T19:48:29.694" v="3" actId="20577"/>
+        <pc:sldMkLst>
+          <pc:docMk/>
+          <pc:sldMk cId="3654597332" sldId="1418"/>
+        </pc:sldMkLst>
+        <pc:spChg chg="mod">
+          <ac:chgData name="KRASIC Srdjan (OP-EXT)" userId="S::srdjan.krasic@ext.ec.europa.eu::6da91b18-32dc-43bc-a9cc-2ff6f82cb0e8" providerId="AD" clId="Web-{EF396895-D3C6-4FE9-CA0B-9A5304DD48B9}" dt="2026-06-08T19:48:29.694" v="3" actId="20577"/>
+          <ac:spMkLst>
+            <pc:docMk/>
+            <pc:sldMk cId="3654597332" sldId="1418"/>
+            <ac:spMk id="2" creationId="{D70C2FC5-1B46-B4E4-C31E-468AA17263D3}"/>
+          </ac:spMkLst>
+        </pc:spChg>
+      </pc:sldChg>
+      <pc:sldChg chg="modSp">
+        <pc:chgData name="KRASIC Srdjan (OP-EXT)" userId="S::srdjan.krasic@ext.ec.europa.eu::6da91b18-32dc-43bc-a9cc-2ff6f82cb0e8" providerId="AD" clId="Web-{EF396895-D3C6-4FE9-CA0B-9A5304DD48B9}" dt="2026-06-08T19:48:36.569" v="4" actId="20577"/>
+        <pc:sldMkLst>
+          <pc:docMk/>
+          <pc:sldMk cId="1849753633" sldId="1419"/>
+        </pc:sldMkLst>
+        <pc:spChg chg="mod">
+          <ac:chgData name="KRASIC Srdjan (OP-EXT)" userId="S::srdjan.krasic@ext.ec.europa.eu::6da91b18-32dc-43bc-a9cc-2ff6f82cb0e8" providerId="AD" clId="Web-{EF396895-D3C6-4FE9-CA0B-9A5304DD48B9}" dt="2026-06-08T19:48:36.569" v="4" actId="20577"/>
+          <ac:spMkLst>
+            <pc:docMk/>
+            <pc:sldMk cId="1849753633" sldId="1419"/>
+            <ac:spMk id="2" creationId="{0ED33EA1-CB60-0A17-FE41-56415847B7AA}"/>
+          </ac:spMkLst>
+        </pc:spChg>
+      </pc:sldChg>
+      <pc:sldChg chg="modSp">
+        <pc:chgData name="KRASIC Srdjan (OP-EXT)" userId="S::srdjan.krasic@ext.ec.europa.eu::6da91b18-32dc-43bc-a9cc-2ff6f82cb0e8" providerId="AD" clId="Web-{EF396895-D3C6-4FE9-CA0B-9A5304DD48B9}" dt="2026-06-08T19:48:21.052" v="2" actId="14100"/>
+        <pc:sldMkLst>
+          <pc:docMk/>
+          <pc:sldMk cId="1360176188" sldId="1420"/>
+        </pc:sldMkLst>
+        <pc:spChg chg="mod">
+          <ac:chgData name="KRASIC Srdjan (OP-EXT)" userId="S::srdjan.krasic@ext.ec.europa.eu::6da91b18-32dc-43bc-a9cc-2ff6f82cb0e8" providerId="AD" clId="Web-{EF396895-D3C6-4FE9-CA0B-9A5304DD48B9}" dt="2026-06-08T19:48:21.052" v="2" actId="14100"/>
+          <ac:spMkLst>
+            <pc:docMk/>
+            <pc:sldMk cId="1360176188" sldId="1420"/>
+            <ac:spMk id="2" creationId="{557D2D34-DE56-675F-B9BD-085A037D07BA}"/>
+          </ac:spMkLst>
+        </pc:spChg>
+      </pc:sldChg>
+    </pc:docChg>
+  </pc:docChgLst>
+  <pc:docChgLst>
+    <pc:chgData name="DONOHOE Paul (OP-EXT)" userId="S::paul.donohoe@ext.publications.europa.eu::c9df9133-e9aa-401a-a047-69aff1aabaa4" providerId="AD" clId="Web-{F11732D0-C217-2677-E44D-1D353484A412}"/>
+    <pc:docChg chg="addSld delSld modSld modSection">
+      <pc:chgData name="DONOHOE Paul (OP-EXT)" userId="S::paul.donohoe@ext.publications.europa.eu::c9df9133-e9aa-401a-a047-69aff1aabaa4" providerId="AD" clId="Web-{F11732D0-C217-2677-E44D-1D353484A412}" dt="2026-06-01T14:12:44.038" v="283"/>
+      <pc:docMkLst>
+        <pc:docMk/>
+      </pc:docMkLst>
+      <pc:sldChg chg="modSp modNotes">
+        <pc:chgData name="DONOHOE Paul (OP-EXT)" userId="S::paul.donohoe@ext.publications.europa.eu::c9df9133-e9aa-401a-a047-69aff1aabaa4" providerId="AD" clId="Web-{F11732D0-C217-2677-E44D-1D353484A412}" dt="2026-06-01T14:06:13.089" v="148"/>
+        <pc:sldMkLst>
+          <pc:docMk/>
+          <pc:sldMk cId="255292099" sldId="258"/>
+        </pc:sldMkLst>
+        <pc:spChg chg="mod">
+          <ac:chgData name="DONOHOE Paul (OP-EXT)" userId="S::paul.donohoe@ext.publications.europa.eu::c9df9133-e9aa-401a-a047-69aff1aabaa4" providerId="AD" clId="Web-{F11732D0-C217-2677-E44D-1D353484A412}" dt="2026-06-01T13:32:45.421" v="9" actId="20577"/>
+          <ac:spMkLst>
+            <pc:docMk/>
+            <pc:sldMk cId="255292099" sldId="258"/>
+            <ac:spMk id="9" creationId="{67AD3164-9F40-E8FE-4B28-F9581136DD43}"/>
+          </ac:spMkLst>
+        </pc:spChg>
+      </pc:sldChg>
+      <pc:sldChg chg="modSp modNotes">
+        <pc:chgData name="DONOHOE Paul (OP-EXT)" userId="S::paul.donohoe@ext.publications.europa.eu::c9df9133-e9aa-401a-a047-69aff1aabaa4" providerId="AD" clId="Web-{F11732D0-C217-2677-E44D-1D353484A412}" dt="2026-06-01T14:04:35.788" v="143"/>
+        <pc:sldMkLst>
+          <pc:docMk/>
+          <pc:sldMk cId="2419242855" sldId="1403"/>
+        </pc:sldMkLst>
+        <pc:spChg chg="mod">
+          <ac:chgData name="DONOHOE Paul (OP-EXT)" userId="S::paul.donohoe@ext.publications.europa.eu::c9df9133-e9aa-401a-a047-69aff1aabaa4" providerId="AD" clId="Web-{F11732D0-C217-2677-E44D-1D353484A412}" dt="2026-06-01T13:33:35.094" v="10" actId="20577"/>
+          <ac:spMkLst>
+            <pc:docMk/>
+            <pc:sldMk cId="2419242855" sldId="1403"/>
+            <ac:spMk id="2" creationId="{F20262FE-51C3-9547-9ED8-C7F938F2B0AA}"/>
+          </ac:spMkLst>
+        </pc:spChg>
+        <pc:spChg chg="mod">
+          <ac:chgData name="DONOHOE Paul (OP-EXT)" userId="S::paul.donohoe@ext.publications.europa.eu::c9df9133-e9aa-401a-a047-69aff1aabaa4" providerId="AD" clId="Web-{F11732D0-C217-2677-E44D-1D353484A412}" dt="2026-06-01T14:03:29.130" v="90" actId="20577"/>
+          <ac:spMkLst>
+            <pc:docMk/>
+            <pc:sldMk cId="2419242855" sldId="1403"/>
+            <ac:spMk id="3" creationId="{C76EEE32-05B1-3943-B6B7-F172254DA883}"/>
+          </ac:spMkLst>
+        </pc:spChg>
+      </pc:sldChg>
+      <pc:sldChg chg="modSp modNotes">
+        <pc:chgData name="DONOHOE Paul (OP-EXT)" userId="S::paul.donohoe@ext.publications.europa.eu::c9df9133-e9aa-401a-a047-69aff1aabaa4" providerId="AD" clId="Web-{F11732D0-C217-2677-E44D-1D353484A412}" dt="2026-06-01T14:05:58.666" v="145"/>
+        <pc:sldMkLst>
+          <pc:docMk/>
+          <pc:sldMk cId="3700328532" sldId="1408"/>
+        </pc:sldMkLst>
+        <pc:spChg chg="mod">
+          <ac:chgData name="DONOHOE Paul (OP-EXT)" userId="S::paul.donohoe@ext.publications.europa.eu::c9df9133-e9aa-401a-a047-69aff1aabaa4" providerId="AD" clId="Web-{F11732D0-C217-2677-E44D-1D353484A412}" dt="2026-06-01T13:33:42.188" v="11" actId="20577"/>
+          <ac:spMkLst>
+            <pc:docMk/>
+            <pc:sldMk cId="3700328532" sldId="1408"/>
+            <ac:spMk id="2" creationId="{445F8046-0E9D-FCCE-E14C-F03BD8373AA3}"/>
+          </ac:spMkLst>
+        </pc:spChg>
+      </pc:sldChg>
+      <pc:sldChg chg="modSp modNotes">
+        <pc:chgData name="DONOHOE Paul (OP-EXT)" userId="S::paul.donohoe@ext.publications.europa.eu::c9df9133-e9aa-401a-a047-69aff1aabaa4" providerId="AD" clId="Web-{F11732D0-C217-2677-E44D-1D353484A412}" dt="2026-06-01T14:12:44.038" v="283"/>
+        <pc:sldMkLst>
+          <pc:docMk/>
+          <pc:sldMk cId="3654597332" sldId="1418"/>
+        </pc:sldMkLst>
+        <pc:spChg chg="mod">
+          <ac:chgData name="DONOHOE Paul (OP-EXT)" userId="S::paul.donohoe@ext.publications.europa.eu::c9df9133-e9aa-401a-a047-69aff1aabaa4" providerId="AD" clId="Web-{F11732D0-C217-2677-E44D-1D353484A412}" dt="2026-06-01T13:52:55.652" v="58" actId="20577"/>
+          <ac:spMkLst>
+            <pc:docMk/>
+            <pc:sldMk cId="3654597332" sldId="1418"/>
+            <ac:spMk id="5" creationId="{F9364E06-FCDE-3F7A-A668-7F06980C1C5C}"/>
+          </ac:spMkLst>
+        </pc:spChg>
+      </pc:sldChg>
+      <pc:sldChg chg="modNotes">
+        <pc:chgData name="DONOHOE Paul (OP-EXT)" userId="S::paul.donohoe@ext.publications.europa.eu::c9df9133-e9aa-401a-a047-69aff1aabaa4" providerId="AD" clId="Web-{F11732D0-C217-2677-E44D-1D353484A412}" dt="2026-06-01T13:58:38.428" v="71"/>
+        <pc:sldMkLst>
+          <pc:docMk/>
+          <pc:sldMk cId="1849753633" sldId="1419"/>
+        </pc:sldMkLst>
+      </pc:sldChg>
+      <pc:sldChg chg="modSp modNotes">
+        <pc:chgData name="DONOHOE Paul (OP-EXT)" userId="S::paul.donohoe@ext.publications.europa.eu::c9df9133-e9aa-401a-a047-69aff1aabaa4" providerId="AD" clId="Web-{F11732D0-C217-2677-E44D-1D353484A412}" dt="2026-06-01T13:48:30.816" v="53"/>
+        <pc:sldMkLst>
+          <pc:docMk/>
+          <pc:sldMk cId="1855452888" sldId="1422"/>
+        </pc:sldMkLst>
+        <pc:spChg chg="mod">
+          <ac:chgData name="DONOHOE Paul (OP-EXT)" userId="S::paul.donohoe@ext.publications.europa.eu::c9df9133-e9aa-401a-a047-69aff1aabaa4" providerId="AD" clId="Web-{F11732D0-C217-2677-E44D-1D353484A412}" dt="2026-06-01T13:47:50.705" v="50" actId="20577"/>
+          <ac:spMkLst>
+            <pc:docMk/>
+            <pc:sldMk cId="1855452888" sldId="1422"/>
+            <ac:spMk id="3" creationId="{7D8A9BDB-FDA7-B411-4B96-2E9F57CB57E2}"/>
+          </ac:spMkLst>
+        </pc:spChg>
+      </pc:sldChg>
+    </pc:docChg>
+  </pc:docChgLst>
+  <pc:docChgLst>
+    <pc:chgData name="DONOHOE Paul (OP-EXT)" userId="S::paul.donohoe@ext.publications.europa.eu::c9df9133-e9aa-401a-a047-69aff1aabaa4" providerId="AD" clId="Web-{CA7D48B9-D6CB-8A7A-C251-630C823E82D8}"/>
+    <pc:docChg chg="modSld">
+      <pc:chgData name="DONOHOE Paul (OP-EXT)" userId="S::paul.donohoe@ext.publications.europa.eu::c9df9133-e9aa-401a-a047-69aff1aabaa4" providerId="AD" clId="Web-{CA7D48B9-D6CB-8A7A-C251-630C823E82D8}" dt="2026-06-01T07:57:16.108" v="79"/>
+      <pc:docMkLst>
+        <pc:docMk/>
+      </pc:docMkLst>
+      <pc:sldChg chg="modNotes">
+        <pc:chgData name="DONOHOE Paul (OP-EXT)" userId="S::paul.donohoe@ext.publications.europa.eu::c9df9133-e9aa-401a-a047-69aff1aabaa4" providerId="AD" clId="Web-{CA7D48B9-D6CB-8A7A-C251-630C823E82D8}" dt="2026-06-01T07:45:42.300" v="68"/>
+        <pc:sldMkLst>
+          <pc:docMk/>
+          <pc:sldMk cId="2699462789" sldId="1417"/>
+        </pc:sldMkLst>
+      </pc:sldChg>
+      <pc:sldChg chg="modNotes">
+        <pc:chgData name="DONOHOE Paul (OP-EXT)" userId="S::paul.donohoe@ext.publications.europa.eu::c9df9133-e9aa-401a-a047-69aff1aabaa4" providerId="AD" clId="Web-{CA7D48B9-D6CB-8A7A-C251-630C823E82D8}" dt="2026-06-01T07:55:58.621" v="72"/>
+        <pc:sldMkLst>
+          <pc:docMk/>
+          <pc:sldMk cId="3654597332" sldId="1418"/>
+        </pc:sldMkLst>
+      </pc:sldChg>
+      <pc:sldChg chg="modNotes">
+        <pc:chgData name="DONOHOE Paul (OP-EXT)" userId="S::paul.donohoe@ext.publications.europa.eu::c9df9133-e9aa-401a-a047-69aff1aabaa4" providerId="AD" clId="Web-{CA7D48B9-D6CB-8A7A-C251-630C823E82D8}" dt="2026-06-01T07:57:16.108" v="79"/>
+        <pc:sldMkLst>
+          <pc:docMk/>
+          <pc:sldMk cId="1849753633" sldId="1419"/>
+        </pc:sldMkLst>
+      </pc:sldChg>
+    </pc:docChg>
+  </pc:docChgLst>
+  <pc:docChgLst>
+    <pc:chgData clId="Web-{A8406028-A772-858E-35E4-918BBF61E412}"/>
+    <pc:docChg chg="modSld">
+      <pc:chgData name="" userId="" providerId="" clId="Web-{A8406028-A772-858E-35E4-918BBF61E412}" dt="2026-05-21T13:49:11.986" v="0" actId="20577"/>
+      <pc:docMkLst>
+        <pc:docMk/>
+      </pc:docMkLst>
+      <pc:sldChg chg="modSp">
+        <pc:chgData name="" userId="" providerId="" clId="Web-{A8406028-A772-858E-35E4-918BBF61E412}" dt="2026-05-21T13:49:11.986" v="0" actId="20577"/>
+        <pc:sldMkLst>
+          <pc:docMk/>
+          <pc:sldMk cId="1855452888" sldId="1422"/>
+        </pc:sldMkLst>
+        <pc:spChg chg="mod">
+          <ac:chgData name="" userId="" providerId="" clId="Web-{A8406028-A772-858E-35E4-918BBF61E412}" dt="2026-05-21T13:49:11.986" v="0" actId="20577"/>
+          <ac:spMkLst>
+            <pc:docMk/>
+            <pc:sldMk cId="1855452888" sldId="1422"/>
+            <ac:spMk id="3" creationId="{7D8A9BDB-FDA7-B411-4B96-2E9F57CB57E2}"/>
+          </ac:spMkLst>
+        </pc:spChg>
+      </pc:sldChg>
+    </pc:docChg>
+  </pc:docChgLst>
+  <pc:docChgLst>
+    <pc:chgData name="DONOHOE Paul (OP-EXT)" userId="S::paul.donohoe@ext.publications.europa.eu::c9df9133-e9aa-401a-a047-69aff1aabaa4" providerId="AD" clId="Web-{08987228-AB28-35EC-B574-F0F35AB6AA5A}"/>
+    <pc:docChg chg="modSld">
+      <pc:chgData name="DONOHOE Paul (OP-EXT)" userId="S::paul.donohoe@ext.publications.europa.eu::c9df9133-e9aa-401a-a047-69aff1aabaa4" providerId="AD" clId="Web-{08987228-AB28-35EC-B574-F0F35AB6AA5A}" dt="2026-05-27T08:32:29.692" v="331" actId="20577"/>
+      <pc:docMkLst>
+        <pc:docMk/>
+      </pc:docMkLst>
+      <pc:sldChg chg="modSp">
+        <pc:chgData name="DONOHOE Paul (OP-EXT)" userId="S::paul.donohoe@ext.publications.europa.eu::c9df9133-e9aa-401a-a047-69aff1aabaa4" providerId="AD" clId="Web-{08987228-AB28-35EC-B574-F0F35AB6AA5A}" dt="2026-05-27T08:07:17.841" v="132" actId="20577"/>
+        <pc:sldMkLst>
+          <pc:docMk/>
+          <pc:sldMk cId="2699462789" sldId="1417"/>
+        </pc:sldMkLst>
+        <pc:spChg chg="mod">
+          <ac:chgData name="DONOHOE Paul (OP-EXT)" userId="S::paul.donohoe@ext.publications.europa.eu::c9df9133-e9aa-401a-a047-69aff1aabaa4" providerId="AD" clId="Web-{08987228-AB28-35EC-B574-F0F35AB6AA5A}" dt="2026-05-27T08:07:17.841" v="132" actId="20577"/>
+          <ac:spMkLst>
+            <pc:docMk/>
+            <pc:sldMk cId="2699462789" sldId="1417"/>
+            <ac:spMk id="5" creationId="{9ABF5060-D86C-F134-069D-7748A6B0A502}"/>
+          </ac:spMkLst>
+        </pc:spChg>
+      </pc:sldChg>
+      <pc:sldChg chg="modSp">
+        <pc:chgData name="DONOHOE Paul (OP-EXT)" userId="S::paul.donohoe@ext.publications.europa.eu::c9df9133-e9aa-401a-a047-69aff1aabaa4" providerId="AD" clId="Web-{08987228-AB28-35EC-B574-F0F35AB6AA5A}" dt="2026-05-27T07:31:38.144" v="110" actId="20577"/>
+        <pc:sldMkLst>
+          <pc:docMk/>
+          <pc:sldMk cId="3654597332" sldId="1418"/>
+        </pc:sldMkLst>
+        <pc:spChg chg="mod">
+          <ac:chgData name="DONOHOE Paul (OP-EXT)" userId="S::paul.donohoe@ext.publications.europa.eu::c9df9133-e9aa-401a-a047-69aff1aabaa4" providerId="AD" clId="Web-{08987228-AB28-35EC-B574-F0F35AB6AA5A}" dt="2026-05-27T07:31:38.144" v="110" actId="20577"/>
+          <ac:spMkLst>
+            <pc:docMk/>
+            <pc:sldMk cId="3654597332" sldId="1418"/>
+            <ac:spMk id="5" creationId="{F9364E06-FCDE-3F7A-A668-7F06980C1C5C}"/>
+          </ac:spMkLst>
+        </pc:spChg>
+      </pc:sldChg>
+      <pc:sldChg chg="modSp">
+        <pc:chgData name="DONOHOE Paul (OP-EXT)" userId="S::paul.donohoe@ext.publications.europa.eu::c9df9133-e9aa-401a-a047-69aff1aabaa4" providerId="AD" clId="Web-{08987228-AB28-35EC-B574-F0F35AB6AA5A}" dt="2026-05-27T07:35:12.144" v="128" actId="20577"/>
+        <pc:sldMkLst>
+          <pc:docMk/>
+          <pc:sldMk cId="1849753633" sldId="1419"/>
+        </pc:sldMkLst>
+        <pc:spChg chg="mod">
+          <ac:chgData name="DONOHOE Paul (OP-EXT)" userId="S::paul.donohoe@ext.publications.europa.eu::c9df9133-e9aa-401a-a047-69aff1aabaa4" providerId="AD" clId="Web-{08987228-AB28-35EC-B574-F0F35AB6AA5A}" dt="2026-05-27T07:35:12.144" v="128" actId="20577"/>
+          <ac:spMkLst>
+            <pc:docMk/>
+            <pc:sldMk cId="1849753633" sldId="1419"/>
+            <ac:spMk id="5" creationId="{6441FC53-4908-2481-AD2C-6F5024EF432F}"/>
+          </ac:spMkLst>
+        </pc:spChg>
+      </pc:sldChg>
+      <pc:sldChg chg="modSp">
+        <pc:chgData name="DONOHOE Paul (OP-EXT)" userId="S::paul.donohoe@ext.publications.europa.eu::c9df9133-e9aa-401a-a047-69aff1aabaa4" providerId="AD" clId="Web-{08987228-AB28-35EC-B574-F0F35AB6AA5A}" dt="2026-05-27T08:32:29.692" v="331" actId="20577"/>
+        <pc:sldMkLst>
+          <pc:docMk/>
+          <pc:sldMk cId="1855452888" sldId="1422"/>
+        </pc:sldMkLst>
+        <pc:spChg chg="mod">
+          <ac:chgData name="DONOHOE Paul (OP-EXT)" userId="S::paul.donohoe@ext.publications.europa.eu::c9df9133-e9aa-401a-a047-69aff1aabaa4" providerId="AD" clId="Web-{08987228-AB28-35EC-B574-F0F35AB6AA5A}" dt="2026-05-27T08:23:28.447" v="210" actId="20577"/>
+          <ac:spMkLst>
+            <pc:docMk/>
+            <pc:sldMk cId="1855452888" sldId="1422"/>
+            <ac:spMk id="2" creationId="{BBB4B94F-0613-388D-58C2-A94A8C0BE49E}"/>
+          </ac:spMkLst>
+        </pc:spChg>
+        <pc:spChg chg="mod">
+          <ac:chgData name="DONOHOE Paul (OP-EXT)" userId="S::paul.donohoe@ext.publications.europa.eu::c9df9133-e9aa-401a-a047-69aff1aabaa4" providerId="AD" clId="Web-{08987228-AB28-35EC-B574-F0F35AB6AA5A}" dt="2026-05-27T08:32:29.692" v="331" actId="20577"/>
+          <ac:spMkLst>
+            <pc:docMk/>
+            <pc:sldMk cId="1855452888" sldId="1422"/>
+            <ac:spMk id="3" creationId="{7D8A9BDB-FDA7-B411-4B96-2E9F57CB57E2}"/>
+          </ac:spMkLst>
+        </pc:spChg>
+      </pc:sldChg>
+    </pc:docChg>
+  </pc:docChgLst>
+  <pc:docChgLst>
+    <pc:chgData name="DONOHOE Paul (OP-EXT)" userId="S::paul.donohoe@ext.publications.europa.eu::c9df9133-e9aa-401a-a047-69aff1aabaa4" providerId="AD" clId="Web-{079B62D3-76F7-C8C1-3E52-3AC4AE09F1AB}"/>
+    <pc:docChg chg="addSld delSld modSld modSection">
+      <pc:chgData name="DONOHOE Paul (OP-EXT)" userId="S::paul.donohoe@ext.publications.europa.eu::c9df9133-e9aa-401a-a047-69aff1aabaa4" providerId="AD" clId="Web-{079B62D3-76F7-C8C1-3E52-3AC4AE09F1AB}" dt="2026-05-22T12:55:25.256" v="131" actId="20577"/>
+      <pc:docMkLst>
+        <pc:docMk/>
+      </pc:docMkLst>
+      <pc:sldChg chg="modSp">
+        <pc:chgData name="DONOHOE Paul (OP-EXT)" userId="S::paul.donohoe@ext.publications.europa.eu::c9df9133-e9aa-401a-a047-69aff1aabaa4" providerId="AD" clId="Web-{079B62D3-76F7-C8C1-3E52-3AC4AE09F1AB}" dt="2026-05-22T12:52:03.014" v="55" actId="20577"/>
+        <pc:sldMkLst>
+          <pc:docMk/>
+          <pc:sldMk cId="2419242855" sldId="1403"/>
+        </pc:sldMkLst>
+        <pc:spChg chg="mod">
+          <ac:chgData name="DONOHOE Paul (OP-EXT)" userId="S::paul.donohoe@ext.publications.europa.eu::c9df9133-e9aa-401a-a047-69aff1aabaa4" providerId="AD" clId="Web-{079B62D3-76F7-C8C1-3E52-3AC4AE09F1AB}" dt="2026-05-22T12:52:03.014" v="55" actId="20577"/>
+          <ac:spMkLst>
+            <pc:docMk/>
+            <pc:sldMk cId="2419242855" sldId="1403"/>
+            <ac:spMk id="3" creationId="{C76EEE32-05B1-3943-B6B7-F172254DA883}"/>
+          </ac:spMkLst>
+        </pc:spChg>
+      </pc:sldChg>
+      <pc:sldChg chg="modSp">
+        <pc:chgData name="DONOHOE Paul (OP-EXT)" userId="S::paul.donohoe@ext.publications.europa.eu::c9df9133-e9aa-401a-a047-69aff1aabaa4" providerId="AD" clId="Web-{079B62D3-76F7-C8C1-3E52-3AC4AE09F1AB}" dt="2026-05-22T11:31:19.688" v="52" actId="20577"/>
+        <pc:sldMkLst>
+          <pc:docMk/>
+          <pc:sldMk cId="3700328532" sldId="1408"/>
+        </pc:sldMkLst>
+        <pc:spChg chg="mod">
+          <ac:chgData name="DONOHOE Paul (OP-EXT)" userId="S::paul.donohoe@ext.publications.europa.eu::c9df9133-e9aa-401a-a047-69aff1aabaa4" providerId="AD" clId="Web-{079B62D3-76F7-C8C1-3E52-3AC4AE09F1AB}" dt="2026-05-22T11:31:19.688" v="52" actId="20577"/>
+          <ac:spMkLst>
+            <pc:docMk/>
+            <pc:sldMk cId="3700328532" sldId="1408"/>
+            <ac:spMk id="3" creationId="{93CE2629-F9EF-7A93-FD2C-D3730294CEAF}"/>
+          </ac:spMkLst>
+        </pc:spChg>
+      </pc:sldChg>
+      <pc:sldChg chg="addSp delSp modSp">
+        <pc:chgData name="DONOHOE Paul (OP-EXT)" userId="S::paul.donohoe@ext.publications.europa.eu::c9df9133-e9aa-401a-a047-69aff1aabaa4" providerId="AD" clId="Web-{079B62D3-76F7-C8C1-3E52-3AC4AE09F1AB}" dt="2026-05-22T12:55:25.256" v="131" actId="20577"/>
+        <pc:sldMkLst>
+          <pc:docMk/>
+          <pc:sldMk cId="1855452888" sldId="1422"/>
+        </pc:sldMkLst>
+        <pc:spChg chg="mod">
+          <ac:chgData name="DONOHOE Paul (OP-EXT)" userId="S::paul.donohoe@ext.publications.europa.eu::c9df9133-e9aa-401a-a047-69aff1aabaa4" providerId="AD" clId="Web-{079B62D3-76F7-C8C1-3E52-3AC4AE09F1AB}" dt="2026-05-22T12:55:25.256" v="131" actId="20577"/>
+          <ac:spMkLst>
+            <pc:docMk/>
+            <pc:sldMk cId="1855452888" sldId="1422"/>
+            <ac:spMk id="3" creationId="{7D8A9BDB-FDA7-B411-4B96-2E9F57CB57E2}"/>
+          </ac:spMkLst>
+        </pc:spChg>
+      </pc:sldChg>
+    </pc:docChg>
+  </pc:docChgLst>
+  <pc:docChgLst>
+    <pc:chgData name="DONOHOE Paul (OP-EXT)" userId="c9df9133-e9aa-401a-a047-69aff1aabaa4" providerId="ADAL" clId="{FF0E4331-F76A-49E2-AE24-5ABE3B435529}"/>
+    <pc:docChg chg="custSel modSld">
+      <pc:chgData name="DONOHOE Paul (OP-EXT)" userId="c9df9133-e9aa-401a-a047-69aff1aabaa4" providerId="ADAL" clId="{FF0E4331-F76A-49E2-AE24-5ABE3B435529}" dt="2026-06-09T11:52:40.505" v="290" actId="20577"/>
+      <pc:docMkLst>
+        <pc:docMk/>
+      </pc:docMkLst>
+      <pc:sldChg chg="modSp mod">
+        <pc:chgData name="DONOHOE Paul (OP-EXT)" userId="c9df9133-e9aa-401a-a047-69aff1aabaa4" providerId="ADAL" clId="{FF0E4331-F76A-49E2-AE24-5ABE3B435529}" dt="2026-06-09T09:34:16.903" v="52" actId="20577"/>
+        <pc:sldMkLst>
+          <pc:docMk/>
+          <pc:sldMk cId="2419242855" sldId="1403"/>
+        </pc:sldMkLst>
+        <pc:spChg chg="mod">
+          <ac:chgData name="DONOHOE Paul (OP-EXT)" userId="c9df9133-e9aa-401a-a047-69aff1aabaa4" providerId="ADAL" clId="{FF0E4331-F76A-49E2-AE24-5ABE3B435529}" dt="2026-06-09T09:34:16.903" v="52" actId="20577"/>
+          <ac:spMkLst>
+            <pc:docMk/>
+            <pc:sldMk cId="2419242855" sldId="1403"/>
+            <ac:spMk id="3" creationId="{C76EEE32-05B1-3943-B6B7-F172254DA883}"/>
+          </ac:spMkLst>
+        </pc:spChg>
+      </pc:sldChg>
+      <pc:sldChg chg="modNotesTx">
+        <pc:chgData name="DONOHOE Paul (OP-EXT)" userId="c9df9133-e9aa-401a-a047-69aff1aabaa4" providerId="ADAL" clId="{FF0E4331-F76A-49E2-AE24-5ABE3B435529}" dt="2026-06-09T11:52:40.505" v="290" actId="20577"/>
+        <pc:sldMkLst>
+          <pc:docMk/>
+          <pc:sldMk cId="3654597332" sldId="1418"/>
+        </pc:sldMkLst>
+      </pc:sldChg>
+    </pc:docChg>
+  </pc:docChgLst>
+  <pc:docChgLst>
+    <pc:chgData name="KRASIC Srdjan (OP-EXT)" userId="S::srdjan.krasic@ext.ec.europa.eu::6da91b18-32dc-43bc-a9cc-2ff6f82cb0e8" providerId="AD" clId="Web-{A8406028-A772-858E-35E4-918BBF61E412}"/>
+    <pc:docChg chg="addSld modSld sldOrd modSection">
+      <pc:chgData name="KRASIC Srdjan (OP-EXT)" userId="S::srdjan.krasic@ext.ec.europa.eu::6da91b18-32dc-43bc-a9cc-2ff6f82cb0e8" providerId="AD" clId="Web-{A8406028-A772-858E-35E4-918BBF61E412}" dt="2026-05-21T14:16:06.636" v="145" actId="20577"/>
+      <pc:docMkLst>
+        <pc:docMk/>
+      </pc:docMkLst>
+      <pc:sldChg chg="modSp">
+        <pc:chgData name="KRASIC Srdjan (OP-EXT)" userId="S::srdjan.krasic@ext.ec.europa.eu::6da91b18-32dc-43bc-a9cc-2ff6f82cb0e8" providerId="AD" clId="Web-{A8406028-A772-858E-35E4-918BBF61E412}" dt="2026-05-21T14:04:09.944" v="115" actId="20577"/>
+        <pc:sldMkLst>
+          <pc:docMk/>
+          <pc:sldMk cId="255292099" sldId="258"/>
+        </pc:sldMkLst>
+        <pc:spChg chg="mod">
+          <ac:chgData name="KRASIC Srdjan (OP-EXT)" userId="S::srdjan.krasic@ext.ec.europa.eu::6da91b18-32dc-43bc-a9cc-2ff6f82cb0e8" providerId="AD" clId="Web-{A8406028-A772-858E-35E4-918BBF61E412}" dt="2026-05-21T14:04:09.944" v="115" actId="20577"/>
+          <ac:spMkLst>
+            <pc:docMk/>
+            <pc:sldMk cId="255292099" sldId="258"/>
+            <ac:spMk id="9" creationId="{67AD3164-9F40-E8FE-4B28-F9581136DD43}"/>
+          </ac:spMkLst>
+        </pc:spChg>
+      </pc:sldChg>
+      <pc:sldChg chg="modSp">
+        <pc:chgData name="KRASIC Srdjan (OP-EXT)" userId="S::srdjan.krasic@ext.ec.europa.eu::6da91b18-32dc-43bc-a9cc-2ff6f82cb0e8" providerId="AD" clId="Web-{A8406028-A772-858E-35E4-918BBF61E412}" dt="2026-05-21T13:39:33.552" v="17"/>
+        <pc:sldMkLst>
+          <pc:docMk/>
+          <pc:sldMk cId="981817496" sldId="1400"/>
+        </pc:sldMkLst>
+        <pc:graphicFrameChg chg="mod modGraphic">
+          <ac:chgData name="KRASIC Srdjan (OP-EXT)" userId="S::srdjan.krasic@ext.ec.europa.eu::6da91b18-32dc-43bc-a9cc-2ff6f82cb0e8" providerId="AD" clId="Web-{A8406028-A772-858E-35E4-918BBF61E412}" dt="2026-05-21T13:39:33.552" v="17"/>
+          <ac:graphicFrameMkLst>
+            <pc:docMk/>
+            <pc:sldMk cId="981817496" sldId="1400"/>
+            <ac:graphicFrameMk id="4" creationId="{42F66917-925C-88A0-2E14-9BC390E596EE}"/>
+          </ac:graphicFrameMkLst>
+        </pc:graphicFrameChg>
+      </pc:sldChg>
+      <pc:sldChg chg="modSp">
+        <pc:chgData name="KRASIC Srdjan (OP-EXT)" userId="S::srdjan.krasic@ext.ec.europa.eu::6da91b18-32dc-43bc-a9cc-2ff6f82cb0e8" providerId="AD" clId="Web-{A8406028-A772-858E-35E4-918BBF61E412}" dt="2026-05-21T14:16:06.636" v="145" actId="20577"/>
+        <pc:sldMkLst>
+          <pc:docMk/>
+          <pc:sldMk cId="2419242855" sldId="1403"/>
+        </pc:sldMkLst>
+        <pc:spChg chg="mod">
+          <ac:chgData name="KRASIC Srdjan (OP-EXT)" userId="S::srdjan.krasic@ext.ec.europa.eu::6da91b18-32dc-43bc-a9cc-2ff6f82cb0e8" providerId="AD" clId="Web-{A8406028-A772-858E-35E4-918BBF61E412}" dt="2026-05-21T14:05:04.163" v="117" actId="20577"/>
+          <ac:spMkLst>
+            <pc:docMk/>
+            <pc:sldMk cId="2419242855" sldId="1403"/>
+            <ac:spMk id="2" creationId="{F20262FE-51C3-9547-9ED8-C7F938F2B0AA}"/>
+          </ac:spMkLst>
+        </pc:spChg>
+        <pc:spChg chg="mod">
+          <ac:chgData name="KRASIC Srdjan (OP-EXT)" userId="S::srdjan.krasic@ext.ec.europa.eu::6da91b18-32dc-43bc-a9cc-2ff6f82cb0e8" providerId="AD" clId="Web-{A8406028-A772-858E-35E4-918BBF61E412}" dt="2026-05-21T14:16:06.636" v="145" actId="20577"/>
+          <ac:spMkLst>
+            <pc:docMk/>
+            <pc:sldMk cId="2419242855" sldId="1403"/>
+            <ac:spMk id="3" creationId="{C76EEE32-05B1-3943-B6B7-F172254DA883}"/>
+          </ac:spMkLst>
+        </pc:spChg>
+      </pc:sldChg>
+      <pc:sldChg chg="modSp">
+        <pc:chgData name="KRASIC Srdjan (OP-EXT)" userId="S::srdjan.krasic@ext.ec.europa.eu::6da91b18-32dc-43bc-a9cc-2ff6f82cb0e8" providerId="AD" clId="Web-{A8406028-A772-858E-35E4-918BBF61E412}" dt="2026-05-21T14:05:16.601" v="119" actId="20577"/>
+        <pc:sldMkLst>
+          <pc:docMk/>
+          <pc:sldMk cId="3700328532" sldId="1408"/>
+        </pc:sldMkLst>
+        <pc:spChg chg="mod">
+          <ac:chgData name="KRASIC Srdjan (OP-EXT)" userId="S::srdjan.krasic@ext.ec.europa.eu::6da91b18-32dc-43bc-a9cc-2ff6f82cb0e8" providerId="AD" clId="Web-{A8406028-A772-858E-35E4-918BBF61E412}" dt="2026-05-21T14:05:16.601" v="119" actId="20577"/>
+          <ac:spMkLst>
+            <pc:docMk/>
+            <pc:sldMk cId="3700328532" sldId="1408"/>
+            <ac:spMk id="2" creationId="{445F8046-0E9D-FCCE-E14C-F03BD8373AA3}"/>
+          </ac:spMkLst>
+        </pc:spChg>
+        <pc:spChg chg="mod">
+          <ac:chgData name="KRASIC Srdjan (OP-EXT)" userId="S::srdjan.krasic@ext.ec.europa.eu::6da91b18-32dc-43bc-a9cc-2ff6f82cb0e8" providerId="AD" clId="Web-{A8406028-A772-858E-35E4-918BBF61E412}" dt="2026-05-21T13:58:58.271" v="76" actId="20577"/>
+          <ac:spMkLst>
+            <pc:docMk/>
+            <pc:sldMk cId="3700328532" sldId="1408"/>
+            <ac:spMk id="3" creationId="{93CE2629-F9EF-7A93-FD2C-D3730294CEAF}"/>
+          </ac:spMkLst>
+        </pc:spChg>
+      </pc:sldChg>
+      <pc:sldChg chg="delSp modSp add ord replId">
+        <pc:chgData name="KRASIC Srdjan (OP-EXT)" userId="S::srdjan.krasic@ext.ec.europa.eu::6da91b18-32dc-43bc-a9cc-2ff6f82cb0e8" providerId="AD" clId="Web-{A8406028-A772-858E-35E4-918BBF61E412}" dt="2026-05-21T13:49:05.468" v="51" actId="20577"/>
+        <pc:sldMkLst>
+          <pc:docMk/>
+          <pc:sldMk cId="1855452888" sldId="1422"/>
+        </pc:sldMkLst>
+        <pc:spChg chg="mod">
+          <ac:chgData name="KRASIC Srdjan (OP-EXT)" userId="S::srdjan.krasic@ext.ec.europa.eu::6da91b18-32dc-43bc-a9cc-2ff6f82cb0e8" providerId="AD" clId="Web-{A8406028-A772-858E-35E4-918BBF61E412}" dt="2026-05-21T13:48:40.874" v="40" actId="20577"/>
+          <ac:spMkLst>
+            <pc:docMk/>
+            <pc:sldMk cId="1855452888" sldId="1422"/>
+            <ac:spMk id="2" creationId="{BBB4B94F-0613-388D-58C2-A94A8C0BE49E}"/>
+          </ac:spMkLst>
+        </pc:spChg>
+        <pc:spChg chg="mod">
+          <ac:chgData name="KRASIC Srdjan (OP-EXT)" userId="S::srdjan.krasic@ext.ec.europa.eu::6da91b18-32dc-43bc-a9cc-2ff6f82cb0e8" providerId="AD" clId="Web-{A8406028-A772-858E-35E4-918BBF61E412}" dt="2026-05-21T13:49:05.468" v="51" actId="20577"/>
+          <ac:spMkLst>
+            <pc:docMk/>
+            <pc:sldMk cId="1855452888" sldId="1422"/>
+            <ac:spMk id="3" creationId="{7D8A9BDB-FDA7-B411-4B96-2E9F57CB57E2}"/>
+          </ac:spMkLst>
+        </pc:spChg>
+      </pc:sldChg>
+    </pc:docChg>
+  </pc:docChgLst>
+  <pc:docChgLst>
+    <pc:chgData name="YFANTI Sevasti (OP-EXT)" userId="S::sevasti.yfanti@ext.ec.europa.eu::7c42bec1-26c8-4f31-ac03-7337768c55f5" providerId="AD" clId="Web-{BE359CB9-F3B2-7C44-DA59-701EA4C9D921}"/>
+    <pc:docChg chg="modSld">
+      <pc:chgData name="YFANTI Sevasti (OP-EXT)" userId="S::sevasti.yfanti@ext.ec.europa.eu::7c42bec1-26c8-4f31-ac03-7337768c55f5" providerId="AD" clId="Web-{BE359CB9-F3B2-7C44-DA59-701EA4C9D921}" dt="2026-05-26T14:22:09.559" v="105" actId="20577"/>
+      <pc:docMkLst>
+        <pc:docMk/>
+      </pc:docMkLst>
+      <pc:sldChg chg="modSp">
+        <pc:chgData name="YFANTI Sevasti (OP-EXT)" userId="S::sevasti.yfanti@ext.ec.europa.eu::7c42bec1-26c8-4f31-ac03-7337768c55f5" providerId="AD" clId="Web-{BE359CB9-F3B2-7C44-DA59-701EA4C9D921}" dt="2026-05-26T14:16:45.725" v="5" actId="20577"/>
+        <pc:sldMkLst>
+          <pc:docMk/>
+          <pc:sldMk cId="1360176188" sldId="1420"/>
+        </pc:sldMkLst>
+        <pc:spChg chg="mod">
+          <ac:chgData name="YFANTI Sevasti (OP-EXT)" userId="S::sevasti.yfanti@ext.ec.europa.eu::7c42bec1-26c8-4f31-ac03-7337768c55f5" providerId="AD" clId="Web-{BE359CB9-F3B2-7C44-DA59-701EA4C9D921}" dt="2026-05-26T14:16:45.725" v="5" actId="20577"/>
+          <ac:spMkLst>
+            <pc:docMk/>
+            <pc:sldMk cId="1360176188" sldId="1420"/>
+            <ac:spMk id="9" creationId="{4DFC0EF3-9841-0744-6F72-CB5E722CE34B}"/>
+          </ac:spMkLst>
+        </pc:spChg>
+      </pc:sldChg>
+      <pc:sldChg chg="modSp">
+        <pc:chgData name="YFANTI Sevasti (OP-EXT)" userId="S::sevasti.yfanti@ext.ec.europa.eu::7c42bec1-26c8-4f31-ac03-7337768c55f5" providerId="AD" clId="Web-{BE359CB9-F3B2-7C44-DA59-701EA4C9D921}" dt="2026-05-26T14:22:09.559" v="105" actId="20577"/>
+        <pc:sldMkLst>
+          <pc:docMk/>
+          <pc:sldMk cId="194845558" sldId="1421"/>
+        </pc:sldMkLst>
+        <pc:spChg chg="mod">
+          <ac:chgData name="YFANTI Sevasti (OP-EXT)" userId="S::sevasti.yfanti@ext.ec.europa.eu::7c42bec1-26c8-4f31-ac03-7337768c55f5" providerId="AD" clId="Web-{BE359CB9-F3B2-7C44-DA59-701EA4C9D921}" dt="2026-05-26T14:22:09.559" v="105" actId="20577"/>
+          <ac:spMkLst>
+            <pc:docMk/>
+            <pc:sldMk cId="194845558" sldId="1421"/>
+            <ac:spMk id="4" creationId="{AC195AC9-43A6-048B-382D-618B79F10F7F}"/>
+          </ac:spMkLst>
+        </pc:spChg>
+      </pc:sldChg>
+    </pc:docChg>
+  </pc:docChgLst>
+  <pc:docChgLst>
+    <pc:chgData name="KRASIC Srdjan (OP-EXT)" userId="S::srdjan.krasic@ext.ec.europa.eu::6da91b18-32dc-43bc-a9cc-2ff6f82cb0e8" providerId="AD" clId="Web-{04A35765-5453-51E5-461D-A8E7C1D44C07}"/>
+    <pc:docChg chg="modSld">
+      <pc:chgData name="KRASIC Srdjan (OP-EXT)" userId="S::srdjan.krasic@ext.ec.europa.eu::6da91b18-32dc-43bc-a9cc-2ff6f82cb0e8" providerId="AD" clId="Web-{04A35765-5453-51E5-461D-A8E7C1D44C07}" dt="2026-06-08T19:43:52.271" v="65" actId="20577"/>
+      <pc:docMkLst>
+        <pc:docMk/>
+      </pc:docMkLst>
+      <pc:sldChg chg="modSp">
+        <pc:chgData name="KRASIC Srdjan (OP-EXT)" userId="S::srdjan.krasic@ext.ec.europa.eu::6da91b18-32dc-43bc-a9cc-2ff6f82cb0e8" providerId="AD" clId="Web-{04A35765-5453-51E5-461D-A8E7C1D44C07}" dt="2026-06-08T19:43:52.271" v="65" actId="20577"/>
+        <pc:sldMkLst>
+          <pc:docMk/>
+          <pc:sldMk cId="2419242855" sldId="1403"/>
+        </pc:sldMkLst>
+        <pc:spChg chg="mod">
+          <ac:chgData name="KRASIC Srdjan (OP-EXT)" userId="S::srdjan.krasic@ext.ec.europa.eu::6da91b18-32dc-43bc-a9cc-2ff6f82cb0e8" providerId="AD" clId="Web-{04A35765-5453-51E5-461D-A8E7C1D44C07}" dt="2026-06-08T19:43:52.271" v="65" actId="20577"/>
+          <ac:spMkLst>
+            <pc:docMk/>
+            <pc:sldMk cId="2419242855" sldId="1403"/>
+            <ac:spMk id="3" creationId="{C76EEE32-05B1-3943-B6B7-F172254DA883}"/>
+          </ac:spMkLst>
+        </pc:spChg>
+      </pc:sldChg>
+    </pc:docChg>
+  </pc:docChgLst>
+  <pc:docChgLst>
+    <pc:chgData name="KRASIC Srdjan (OP-EXT)" userId="S::srdjan.krasic@ext.ec.europa.eu::6da91b18-32dc-43bc-a9cc-2ff6f82cb0e8" providerId="AD" clId="Web-{7573E014-B2A5-ACA1-AE5F-33998E947EDA}"/>
+    <pc:docChg chg="modSld">
+      <pc:chgData name="KRASIC Srdjan (OP-EXT)" userId="S::srdjan.krasic@ext.ec.europa.eu::6da91b18-32dc-43bc-a9cc-2ff6f82cb0e8" providerId="AD" clId="Web-{7573E014-B2A5-ACA1-AE5F-33998E947EDA}" dt="2026-05-19T16:26:17.200" v="29" actId="20577"/>
+      <pc:docMkLst>
+        <pc:docMk/>
+      </pc:docMkLst>
+      <pc:sldChg chg="modSp">
+        <pc:chgData name="KRASIC Srdjan (OP-EXT)" userId="S::srdjan.krasic@ext.ec.europa.eu::6da91b18-32dc-43bc-a9cc-2ff6f82cb0e8" providerId="AD" clId="Web-{7573E014-B2A5-ACA1-AE5F-33998E947EDA}" dt="2026-05-19T16:26:17.200" v="29" actId="20577"/>
+        <pc:sldMkLst>
+          <pc:docMk/>
+          <pc:sldMk cId="981817496" sldId="1400"/>
+        </pc:sldMkLst>
+        <pc:spChg chg="mod">
+          <ac:chgData name="KRASIC Srdjan (OP-EXT)" userId="S::srdjan.krasic@ext.ec.europa.eu::6da91b18-32dc-43bc-a9cc-2ff6f82cb0e8" providerId="AD" clId="Web-{7573E014-B2A5-ACA1-AE5F-33998E947EDA}" dt="2026-05-19T16:26:17.200" v="29" actId="20577"/>
+          <ac:spMkLst>
+            <pc:docMk/>
+            <pc:sldMk cId="981817496" sldId="1400"/>
+            <ac:spMk id="2" creationId="{C8B0B79D-8B76-5991-74F0-A1D95062DDAF}"/>
+          </ac:spMkLst>
+        </pc:spChg>
+        <pc:graphicFrameChg chg="mod modGraphic">
+          <ac:chgData name="KRASIC Srdjan (OP-EXT)" userId="S::srdjan.krasic@ext.ec.europa.eu::6da91b18-32dc-43bc-a9cc-2ff6f82cb0e8" providerId="AD" clId="Web-{7573E014-B2A5-ACA1-AE5F-33998E947EDA}" dt="2026-05-19T16:26:05.496" v="28"/>
+          <ac:graphicFrameMkLst>
+            <pc:docMk/>
+            <pc:sldMk cId="981817496" sldId="1400"/>
+            <ac:graphicFrameMk id="4" creationId="{42F66917-925C-88A0-2E14-9BC390E596EE}"/>
+          </ac:graphicFrameMkLst>
+        </pc:graphicFrameChg>
+      </pc:sldChg>
+    </pc:docChg>
+  </pc:docChgLst>
+  <pc:docChgLst>
+    <pc:chgData name="KRASIC Srdjan (OP-EXT)" userId="S::srdjan.krasic@ext.ec.europa.eu::6da91b18-32dc-43bc-a9cc-2ff6f82cb0e8" providerId="AD" clId="Web-{46EBAA28-2E9C-8BFC-3FAB-5A8A4A660D96}"/>
+    <pc:docChg chg="modSld">
+      <pc:chgData name="KRASIC Srdjan (OP-EXT)" userId="S::srdjan.krasic@ext.ec.europa.eu::6da91b18-32dc-43bc-a9cc-2ff6f82cb0e8" providerId="AD" clId="Web-{46EBAA28-2E9C-8BFC-3FAB-5A8A4A660D96}" dt="2026-05-26T09:06:07.562" v="61" actId="20577"/>
+      <pc:docMkLst>
+        <pc:docMk/>
+      </pc:docMkLst>
+      <pc:sldChg chg="modSp">
+        <pc:chgData name="KRASIC Srdjan (OP-EXT)" userId="S::srdjan.krasic@ext.ec.europa.eu::6da91b18-32dc-43bc-a9cc-2ff6f82cb0e8" providerId="AD" clId="Web-{46EBAA28-2E9C-8BFC-3FAB-5A8A4A660D96}" dt="2026-05-26T09:06:07.562" v="61" actId="20577"/>
+        <pc:sldMkLst>
+          <pc:docMk/>
+          <pc:sldMk cId="2419242855" sldId="1403"/>
+        </pc:sldMkLst>
+        <pc:spChg chg="mod">
+          <ac:chgData name="KRASIC Srdjan (OP-EXT)" userId="S::srdjan.krasic@ext.ec.europa.eu::6da91b18-32dc-43bc-a9cc-2ff6f82cb0e8" providerId="AD" clId="Web-{46EBAA28-2E9C-8BFC-3FAB-5A8A4A660D96}" dt="2026-05-26T09:06:07.562" v="61" actId="20577"/>
+          <ac:spMkLst>
+            <pc:docMk/>
+            <pc:sldMk cId="2419242855" sldId="1403"/>
+            <ac:spMk id="3" creationId="{C76EEE32-05B1-3943-B6B7-F172254DA883}"/>
+          </ac:spMkLst>
+        </pc:spChg>
+      </pc:sldChg>
+    </pc:docChg>
+  </pc:docChgLst>
+  <pc:docChgLst>
     <pc:chgData name="ARILLO ARANDA Paloma (OP)" userId="5aac095e-000b-4e56-a478-19e81d922c1e" providerId="ADAL" clId="{BF0765DA-FE31-4851-B5C5-5D37509283C1}"/>
     <pc:docChg chg="undo custSel modSld">
       <pc:chgData name="ARILLO ARANDA Paloma (OP)" userId="5aac095e-000b-4e56-a478-19e81d922c1e" providerId="ADAL" clId="{BF0765DA-FE31-4851-B5C5-5D37509283C1}" dt="2026-06-09T09:06:11.073" v="226" actId="13926"/>
@@ -433,346 +1068,86 @@
     </pc:docChg>
   </pc:docChgLst>
   <pc:docChgLst>
-    <pc:chgData name="KRASIC Srdjan (OP-EXT)" userId="S::srdjan.krasic@ext.ec.europa.eu::6da91b18-32dc-43bc-a9cc-2ff6f82cb0e8" providerId="AD" clId="Web-{46EBAA28-2E9C-8BFC-3FAB-5A8A4A660D96}"/>
-    <pc:docChg chg="modSld">
-      <pc:chgData name="KRASIC Srdjan (OP-EXT)" userId="S::srdjan.krasic@ext.ec.europa.eu::6da91b18-32dc-43bc-a9cc-2ff6f82cb0e8" providerId="AD" clId="Web-{46EBAA28-2E9C-8BFC-3FAB-5A8A4A660D96}" dt="2026-05-26T09:06:07.562" v="61" actId="20577"/>
+    <pc:chgData name="DONOHOE Paul (OP-EXT)" userId="S::paul.donohoe@ext.publications.europa.eu::c9df9133-e9aa-401a-a047-69aff1aabaa4" providerId="AD" clId="Web-{E0019F40-253B-B092-9B57-6C27EB784B89}"/>
+    <pc:docChg chg="modSld sldOrd">
+      <pc:chgData name="DONOHOE Paul (OP-EXT)" userId="S::paul.donohoe@ext.publications.europa.eu::c9df9133-e9aa-401a-a047-69aff1aabaa4" providerId="AD" clId="Web-{E0019F40-253B-B092-9B57-6C27EB784B89}" dt="2026-06-09T08:39:03.392" v="4" actId="20577"/>
       <pc:docMkLst>
         <pc:docMk/>
       </pc:docMkLst>
-      <pc:sldChg chg="modSp">
-        <pc:chgData name="KRASIC Srdjan (OP-EXT)" userId="S::srdjan.krasic@ext.ec.europa.eu::6da91b18-32dc-43bc-a9cc-2ff6f82cb0e8" providerId="AD" clId="Web-{46EBAA28-2E9C-8BFC-3FAB-5A8A4A660D96}" dt="2026-05-26T09:06:07.562" v="61" actId="20577"/>
-        <pc:sldMkLst>
-          <pc:docMk/>
-          <pc:sldMk cId="2419242855" sldId="1403"/>
-        </pc:sldMkLst>
-        <pc:spChg chg="mod">
-          <ac:chgData name="KRASIC Srdjan (OP-EXT)" userId="S::srdjan.krasic@ext.ec.europa.eu::6da91b18-32dc-43bc-a9cc-2ff6f82cb0e8" providerId="AD" clId="Web-{46EBAA28-2E9C-8BFC-3FAB-5A8A4A660D96}" dt="2026-05-26T09:06:07.562" v="61" actId="20577"/>
-          <ac:spMkLst>
-            <pc:docMk/>
-            <pc:sldMk cId="2419242855" sldId="1403"/>
-            <ac:spMk id="3" creationId="{C76EEE32-05B1-3943-B6B7-F172254DA883}"/>
-          </ac:spMkLst>
-        </pc:spChg>
-      </pc:sldChg>
-    </pc:docChg>
-  </pc:docChgLst>
-  <pc:docChgLst>
-    <pc:chgData name="DONOHOE Paul (OP-EXT)" userId="S::paul.donohoe@ext.publications.europa.eu::c9df9133-e9aa-401a-a047-69aff1aabaa4" providerId="AD" clId="Web-{F11732D0-C217-2677-E44D-1D353484A412}"/>
-    <pc:docChg chg="addSld delSld modSld modSection">
-      <pc:chgData name="DONOHOE Paul (OP-EXT)" userId="S::paul.donohoe@ext.publications.europa.eu::c9df9133-e9aa-401a-a047-69aff1aabaa4" providerId="AD" clId="Web-{F11732D0-C217-2677-E44D-1D353484A412}" dt="2026-06-01T14:12:44.038" v="283"/>
-      <pc:docMkLst>
-        <pc:docMk/>
-      </pc:docMkLst>
-      <pc:sldChg chg="modSp modNotes">
-        <pc:chgData name="DONOHOE Paul (OP-EXT)" userId="S::paul.donohoe@ext.publications.europa.eu::c9df9133-e9aa-401a-a047-69aff1aabaa4" providerId="AD" clId="Web-{F11732D0-C217-2677-E44D-1D353484A412}" dt="2026-06-01T14:06:13.089" v="148"/>
-        <pc:sldMkLst>
-          <pc:docMk/>
-          <pc:sldMk cId="255292099" sldId="258"/>
-        </pc:sldMkLst>
-        <pc:spChg chg="mod">
-          <ac:chgData name="DONOHOE Paul (OP-EXT)" userId="S::paul.donohoe@ext.publications.europa.eu::c9df9133-e9aa-401a-a047-69aff1aabaa4" providerId="AD" clId="Web-{F11732D0-C217-2677-E44D-1D353484A412}" dt="2026-06-01T13:32:45.421" v="9" actId="20577"/>
-          <ac:spMkLst>
-            <pc:docMk/>
-            <pc:sldMk cId="255292099" sldId="258"/>
-            <ac:spMk id="9" creationId="{67AD3164-9F40-E8FE-4B28-F9581136DD43}"/>
-          </ac:spMkLst>
-        </pc:spChg>
-      </pc:sldChg>
-      <pc:sldChg chg="modSp modNotes">
-        <pc:chgData name="DONOHOE Paul (OP-EXT)" userId="S::paul.donohoe@ext.publications.europa.eu::c9df9133-e9aa-401a-a047-69aff1aabaa4" providerId="AD" clId="Web-{F11732D0-C217-2677-E44D-1D353484A412}" dt="2026-06-01T14:04:35.788" v="143"/>
-        <pc:sldMkLst>
-          <pc:docMk/>
-          <pc:sldMk cId="2419242855" sldId="1403"/>
-        </pc:sldMkLst>
-        <pc:spChg chg="mod">
-          <ac:chgData name="DONOHOE Paul (OP-EXT)" userId="S::paul.donohoe@ext.publications.europa.eu::c9df9133-e9aa-401a-a047-69aff1aabaa4" providerId="AD" clId="Web-{F11732D0-C217-2677-E44D-1D353484A412}" dt="2026-06-01T13:33:35.094" v="10" actId="20577"/>
-          <ac:spMkLst>
-            <pc:docMk/>
-            <pc:sldMk cId="2419242855" sldId="1403"/>
-            <ac:spMk id="2" creationId="{F20262FE-51C3-9547-9ED8-C7F938F2B0AA}"/>
-          </ac:spMkLst>
-        </pc:spChg>
-        <pc:spChg chg="mod">
-          <ac:chgData name="DONOHOE Paul (OP-EXT)" userId="S::paul.donohoe@ext.publications.europa.eu::c9df9133-e9aa-401a-a047-69aff1aabaa4" providerId="AD" clId="Web-{F11732D0-C217-2677-E44D-1D353484A412}" dt="2026-06-01T14:03:29.130" v="90" actId="20577"/>
-          <ac:spMkLst>
-            <pc:docMk/>
-            <pc:sldMk cId="2419242855" sldId="1403"/>
-            <ac:spMk id="3" creationId="{C76EEE32-05B1-3943-B6B7-F172254DA883}"/>
-          </ac:spMkLst>
-        </pc:spChg>
-      </pc:sldChg>
-      <pc:sldChg chg="modSp modNotes">
-        <pc:chgData name="DONOHOE Paul (OP-EXT)" userId="S::paul.donohoe@ext.publications.europa.eu::c9df9133-e9aa-401a-a047-69aff1aabaa4" providerId="AD" clId="Web-{F11732D0-C217-2677-E44D-1D353484A412}" dt="2026-06-01T14:05:58.666" v="145"/>
-        <pc:sldMkLst>
-          <pc:docMk/>
-          <pc:sldMk cId="3700328532" sldId="1408"/>
-        </pc:sldMkLst>
-        <pc:spChg chg="mod">
-          <ac:chgData name="DONOHOE Paul (OP-EXT)" userId="S::paul.donohoe@ext.publications.europa.eu::c9df9133-e9aa-401a-a047-69aff1aabaa4" providerId="AD" clId="Web-{F11732D0-C217-2677-E44D-1D353484A412}" dt="2026-06-01T13:33:42.188" v="11" actId="20577"/>
-          <ac:spMkLst>
-            <pc:docMk/>
-            <pc:sldMk cId="3700328532" sldId="1408"/>
-            <ac:spMk id="2" creationId="{445F8046-0E9D-FCCE-E14C-F03BD8373AA3}"/>
-          </ac:spMkLst>
-        </pc:spChg>
-      </pc:sldChg>
-      <pc:sldChg chg="modSp modNotes">
-        <pc:chgData name="DONOHOE Paul (OP-EXT)" userId="S::paul.donohoe@ext.publications.europa.eu::c9df9133-e9aa-401a-a047-69aff1aabaa4" providerId="AD" clId="Web-{F11732D0-C217-2677-E44D-1D353484A412}" dt="2026-06-01T14:12:44.038" v="283"/>
+      <pc:sldChg chg="ord">
+        <pc:chgData name="DONOHOE Paul (OP-EXT)" userId="S::paul.donohoe@ext.publications.europa.eu::c9df9133-e9aa-401a-a047-69aff1aabaa4" providerId="AD" clId="Web-{E0019F40-253B-B092-9B57-6C27EB784B89}" dt="2026-06-09T08:36:00.494" v="0"/>
         <pc:sldMkLst>
           <pc:docMk/>
           <pc:sldMk cId="3654597332" sldId="1418"/>
         </pc:sldMkLst>
-        <pc:spChg chg="mod">
-          <ac:chgData name="DONOHOE Paul (OP-EXT)" userId="S::paul.donohoe@ext.publications.europa.eu::c9df9133-e9aa-401a-a047-69aff1aabaa4" providerId="AD" clId="Web-{F11732D0-C217-2677-E44D-1D353484A412}" dt="2026-06-01T13:52:55.652" v="58" actId="20577"/>
-          <ac:spMkLst>
-            <pc:docMk/>
-            <pc:sldMk cId="3654597332" sldId="1418"/>
-            <ac:spMk id="5" creationId="{F9364E06-FCDE-3F7A-A668-7F06980C1C5C}"/>
-          </ac:spMkLst>
-        </pc:spChg>
       </pc:sldChg>
-      <pc:sldChg chg="modNotes">
-        <pc:chgData name="DONOHOE Paul (OP-EXT)" userId="S::paul.donohoe@ext.publications.europa.eu::c9df9133-e9aa-401a-a047-69aff1aabaa4" providerId="AD" clId="Web-{F11732D0-C217-2677-E44D-1D353484A412}" dt="2026-06-01T13:58:38.428" v="71"/>
-        <pc:sldMkLst>
-          <pc:docMk/>
-          <pc:sldMk cId="1849753633" sldId="1419"/>
-        </pc:sldMkLst>
-      </pc:sldChg>
-      <pc:sldChg chg="modSp modNotes">
-        <pc:chgData name="DONOHOE Paul (OP-EXT)" userId="S::paul.donohoe@ext.publications.europa.eu::c9df9133-e9aa-401a-a047-69aff1aabaa4" providerId="AD" clId="Web-{F11732D0-C217-2677-E44D-1D353484A412}" dt="2026-06-01T13:48:30.816" v="53"/>
-        <pc:sldMkLst>
-          <pc:docMk/>
-          <pc:sldMk cId="1855452888" sldId="1422"/>
-        </pc:sldMkLst>
-        <pc:spChg chg="mod">
-          <ac:chgData name="DONOHOE Paul (OP-EXT)" userId="S::paul.donohoe@ext.publications.europa.eu::c9df9133-e9aa-401a-a047-69aff1aabaa4" providerId="AD" clId="Web-{F11732D0-C217-2677-E44D-1D353484A412}" dt="2026-06-01T13:47:50.705" v="50" actId="20577"/>
-          <ac:spMkLst>
-            <pc:docMk/>
-            <pc:sldMk cId="1855452888" sldId="1422"/>
-            <ac:spMk id="3" creationId="{7D8A9BDB-FDA7-B411-4B96-2E9F57CB57E2}"/>
-          </ac:spMkLst>
-        </pc:spChg>
-      </pc:sldChg>
-    </pc:docChg>
-  </pc:docChgLst>
-  <pc:docChgLst>
-    <pc:chgData name="YFANTI Sevasti (OP-EXT)" userId="S::sevasti.yfanti@ext.ec.europa.eu::7c42bec1-26c8-4f31-ac03-7337768c55f5" providerId="AD" clId="Web-{60405500-956F-AB26-A918-8A2BD6DC9882}"/>
-    <pc:docChg chg="modSld">
-      <pc:chgData name="YFANTI Sevasti (OP-EXT)" userId="S::sevasti.yfanti@ext.ec.europa.eu::7c42bec1-26c8-4f31-ac03-7337768c55f5" providerId="AD" clId="Web-{60405500-956F-AB26-A918-8A2BD6DC9882}" dt="2026-06-09T10:40:11.169" v="2" actId="1076"/>
-      <pc:docMkLst>
-        <pc:docMk/>
-      </pc:docMkLst>
-      <pc:sldChg chg="addSp delSp modSp">
-        <pc:chgData name="YFANTI Sevasti (OP-EXT)" userId="S::sevasti.yfanti@ext.ec.europa.eu::7c42bec1-26c8-4f31-ac03-7337768c55f5" providerId="AD" clId="Web-{60405500-956F-AB26-A918-8A2BD6DC9882}" dt="2026-06-09T10:40:11.169" v="2" actId="1076"/>
-        <pc:sldMkLst>
-          <pc:docMk/>
-          <pc:sldMk cId="1360176188" sldId="1420"/>
-        </pc:sldMkLst>
-        <pc:spChg chg="add del mod">
-          <ac:chgData name="YFANTI Sevasti (OP-EXT)" userId="S::sevasti.yfanti@ext.ec.europa.eu::7c42bec1-26c8-4f31-ac03-7337768c55f5" providerId="AD" clId="Web-{60405500-956F-AB26-A918-8A2BD6DC9882}" dt="2026-06-09T10:40:08.060" v="1"/>
-          <ac:spMkLst>
-            <pc:docMk/>
-            <pc:sldMk cId="1360176188" sldId="1420"/>
-            <ac:spMk id="6" creationId="{9C29324B-7559-9556-DEB0-2C0D17EA7BB0}"/>
-          </ac:spMkLst>
-        </pc:spChg>
-        <pc:picChg chg="del">
-          <ac:chgData name="YFANTI Sevasti (OP-EXT)" userId="S::sevasti.yfanti@ext.ec.europa.eu::7c42bec1-26c8-4f31-ac03-7337768c55f5" providerId="AD" clId="Web-{60405500-956F-AB26-A918-8A2BD6DC9882}" dt="2026-06-09T10:40:03.778" v="0"/>
-          <ac:picMkLst>
-            <pc:docMk/>
-            <pc:sldMk cId="1360176188" sldId="1420"/>
-            <ac:picMk id="7" creationId="{D1EDFD0B-61FB-C5A4-1E7F-02A58AED84D3}"/>
-          </ac:picMkLst>
-        </pc:picChg>
-        <pc:picChg chg="add mod ord">
-          <ac:chgData name="YFANTI Sevasti (OP-EXT)" userId="S::sevasti.yfanti@ext.ec.europa.eu::7c42bec1-26c8-4f31-ac03-7337768c55f5" providerId="AD" clId="Web-{60405500-956F-AB26-A918-8A2BD6DC9882}" dt="2026-06-09T10:40:11.169" v="2" actId="1076"/>
-          <ac:picMkLst>
-            <pc:docMk/>
-            <pc:sldMk cId="1360176188" sldId="1420"/>
-            <ac:picMk id="8" creationId="{85F46BA3-E327-7B18-BA56-9099F17828F4}"/>
-          </ac:picMkLst>
-        </pc:picChg>
-      </pc:sldChg>
-    </pc:docChg>
-  </pc:docChgLst>
-  <pc:docChgLst>
-    <pc:chgData name="DONOHOE Paul (OP-EXT)" userId="S::paul.donohoe@ext.publications.europa.eu::c9df9133-e9aa-401a-a047-69aff1aabaa4" providerId="AD" clId="Web-{08987228-AB28-35EC-B574-F0F35AB6AA5A}"/>
-    <pc:docChg chg="modSld">
-      <pc:chgData name="DONOHOE Paul (OP-EXT)" userId="S::paul.donohoe@ext.publications.europa.eu::c9df9133-e9aa-401a-a047-69aff1aabaa4" providerId="AD" clId="Web-{08987228-AB28-35EC-B574-F0F35AB6AA5A}" dt="2026-05-27T08:32:29.692" v="331" actId="20577"/>
-      <pc:docMkLst>
-        <pc:docMk/>
-      </pc:docMkLst>
-      <pc:sldChg chg="modSp">
-        <pc:chgData name="DONOHOE Paul (OP-EXT)" userId="S::paul.donohoe@ext.publications.europa.eu::c9df9133-e9aa-401a-a047-69aff1aabaa4" providerId="AD" clId="Web-{08987228-AB28-35EC-B574-F0F35AB6AA5A}" dt="2026-05-27T08:07:17.841" v="132" actId="20577"/>
-        <pc:sldMkLst>
-          <pc:docMk/>
-          <pc:sldMk cId="2699462789" sldId="1417"/>
-        </pc:sldMkLst>
-        <pc:spChg chg="mod">
-          <ac:chgData name="DONOHOE Paul (OP-EXT)" userId="S::paul.donohoe@ext.publications.europa.eu::c9df9133-e9aa-401a-a047-69aff1aabaa4" providerId="AD" clId="Web-{08987228-AB28-35EC-B574-F0F35AB6AA5A}" dt="2026-05-27T08:07:17.841" v="132" actId="20577"/>
-          <ac:spMkLst>
-            <pc:docMk/>
-            <pc:sldMk cId="2699462789" sldId="1417"/>
-            <ac:spMk id="5" creationId="{9ABF5060-D86C-F134-069D-7748A6B0A502}"/>
-          </ac:spMkLst>
-        </pc:spChg>
-      </pc:sldChg>
-      <pc:sldChg chg="modSp">
-        <pc:chgData name="DONOHOE Paul (OP-EXT)" userId="S::paul.donohoe@ext.publications.europa.eu::c9df9133-e9aa-401a-a047-69aff1aabaa4" providerId="AD" clId="Web-{08987228-AB28-35EC-B574-F0F35AB6AA5A}" dt="2026-05-27T07:31:38.144" v="110" actId="20577"/>
-        <pc:sldMkLst>
-          <pc:docMk/>
-          <pc:sldMk cId="3654597332" sldId="1418"/>
-        </pc:sldMkLst>
-        <pc:spChg chg="mod">
-          <ac:chgData name="DONOHOE Paul (OP-EXT)" userId="S::paul.donohoe@ext.publications.europa.eu::c9df9133-e9aa-401a-a047-69aff1aabaa4" providerId="AD" clId="Web-{08987228-AB28-35EC-B574-F0F35AB6AA5A}" dt="2026-05-27T07:31:38.144" v="110" actId="20577"/>
-          <ac:spMkLst>
-            <pc:docMk/>
-            <pc:sldMk cId="3654597332" sldId="1418"/>
-            <ac:spMk id="5" creationId="{F9364E06-FCDE-3F7A-A668-7F06980C1C5C}"/>
-          </ac:spMkLst>
-        </pc:spChg>
-      </pc:sldChg>
-      <pc:sldChg chg="modSp">
-        <pc:chgData name="DONOHOE Paul (OP-EXT)" userId="S::paul.donohoe@ext.publications.europa.eu::c9df9133-e9aa-401a-a047-69aff1aabaa4" providerId="AD" clId="Web-{08987228-AB28-35EC-B574-F0F35AB6AA5A}" dt="2026-05-27T07:35:12.144" v="128" actId="20577"/>
+      <pc:sldChg chg="modSp modCm">
+        <pc:chgData name="DONOHOE Paul (OP-EXT)" userId="S::paul.donohoe@ext.publications.europa.eu::c9df9133-e9aa-401a-a047-69aff1aabaa4" providerId="AD" clId="Web-{E0019F40-253B-B092-9B57-6C27EB784B89}" dt="2026-06-09T08:39:03.392" v="4" actId="20577"/>
         <pc:sldMkLst>
           <pc:docMk/>
           <pc:sldMk cId="1849753633" sldId="1419"/>
         </pc:sldMkLst>
         <pc:spChg chg="mod">
-          <ac:chgData name="DONOHOE Paul (OP-EXT)" userId="S::paul.donohoe@ext.publications.europa.eu::c9df9133-e9aa-401a-a047-69aff1aabaa4" providerId="AD" clId="Web-{08987228-AB28-35EC-B574-F0F35AB6AA5A}" dt="2026-05-27T07:35:12.144" v="128" actId="20577"/>
+          <ac:chgData name="DONOHOE Paul (OP-EXT)" userId="S::paul.donohoe@ext.publications.europa.eu::c9df9133-e9aa-401a-a047-69aff1aabaa4" providerId="AD" clId="Web-{E0019F40-253B-B092-9B57-6C27EB784B89}" dt="2026-06-09T08:39:03.392" v="4" actId="20577"/>
           <ac:spMkLst>
             <pc:docMk/>
             <pc:sldMk cId="1849753633" sldId="1419"/>
             <ac:spMk id="5" creationId="{6441FC53-4908-2481-AD2C-6F5024EF432F}"/>
           </ac:spMkLst>
         </pc:spChg>
-      </pc:sldChg>
-      <pc:sldChg chg="modSp">
-        <pc:chgData name="DONOHOE Paul (OP-EXT)" userId="S::paul.donohoe@ext.publications.europa.eu::c9df9133-e9aa-401a-a047-69aff1aabaa4" providerId="AD" clId="Web-{08987228-AB28-35EC-B574-F0F35AB6AA5A}" dt="2026-05-27T08:32:29.692" v="331" actId="20577"/>
-        <pc:sldMkLst>
-          <pc:docMk/>
-          <pc:sldMk cId="1855452888" sldId="1422"/>
-        </pc:sldMkLst>
-        <pc:spChg chg="mod">
-          <ac:chgData name="DONOHOE Paul (OP-EXT)" userId="S::paul.donohoe@ext.publications.europa.eu::c9df9133-e9aa-401a-a047-69aff1aabaa4" providerId="AD" clId="Web-{08987228-AB28-35EC-B574-F0F35AB6AA5A}" dt="2026-05-27T08:23:28.447" v="210" actId="20577"/>
-          <ac:spMkLst>
-            <pc:docMk/>
-            <pc:sldMk cId="1855452888" sldId="1422"/>
-            <ac:spMk id="2" creationId="{BBB4B94F-0613-388D-58C2-A94A8C0BE49E}"/>
-          </ac:spMkLst>
-        </pc:spChg>
-        <pc:spChg chg="mod">
-          <ac:chgData name="DONOHOE Paul (OP-EXT)" userId="S::paul.donohoe@ext.publications.europa.eu::c9df9133-e9aa-401a-a047-69aff1aabaa4" providerId="AD" clId="Web-{08987228-AB28-35EC-B574-F0F35AB6AA5A}" dt="2026-05-27T08:32:29.692" v="331" actId="20577"/>
-          <ac:spMkLst>
-            <pc:docMk/>
-            <pc:sldMk cId="1855452888" sldId="1422"/>
-            <ac:spMk id="3" creationId="{7D8A9BDB-FDA7-B411-4B96-2E9F57CB57E2}"/>
-          </ac:spMkLst>
-        </pc:spChg>
+        <pc:extLst>
+          <p:ext xmlns:p="http://schemas.openxmlformats.org/presentationml/2006/main" uri="{D6D511B9-2390-475A-947B-AFAB55BFBCF1}">
+            <pc226:cmChg xmlns:pc226="http://schemas.microsoft.com/office/powerpoint/2022/06/main/command" chg="mod">
+              <pc226:chgData name="DONOHOE Paul (OP-EXT)" userId="S::paul.donohoe@ext.publications.europa.eu::c9df9133-e9aa-401a-a047-69aff1aabaa4" providerId="AD" clId="Web-{E0019F40-253B-B092-9B57-6C27EB784B89}" dt="2026-06-09T08:39:03.392" v="4" actId="20577"/>
+              <pc2:cmMkLst xmlns:pc2="http://schemas.microsoft.com/office/powerpoint/2019/9/main/command">
+                <pc:docMk/>
+                <pc:sldMk cId="1849753633" sldId="1419"/>
+                <pc2:cmMk id="{78C6353A-5ACB-4BA4-BAC1-08708F57B30C}"/>
+              </pc2:cmMkLst>
+            </pc226:cmChg>
+            <pc226:cmChg xmlns:pc226="http://schemas.microsoft.com/office/powerpoint/2022/06/main/command" chg="mod">
+              <pc226:chgData name="DONOHOE Paul (OP-EXT)" userId="S::paul.donohoe@ext.publications.europa.eu::c9df9133-e9aa-401a-a047-69aff1aabaa4" providerId="AD" clId="Web-{E0019F40-253B-B092-9B57-6C27EB784B89}" dt="2026-06-09T08:39:03.392" v="4" actId="20577"/>
+              <pc2:cmMkLst xmlns:pc2="http://schemas.microsoft.com/office/powerpoint/2019/9/main/command">
+                <pc:docMk/>
+                <pc:sldMk cId="1849753633" sldId="1419"/>
+                <pc2:cmMk id="{68AE4B65-1292-4296-8442-41C1DE84C894}"/>
+              </pc2:cmMkLst>
+            </pc226:cmChg>
+          </p:ext>
+        </pc:extLst>
       </pc:sldChg>
     </pc:docChg>
   </pc:docChgLst>
   <pc:docChgLst>
-    <pc:chgData name="KRASIC Srdjan (OP-EXT)" userId="S::srdjan.krasic@ext.ec.europa.eu::6da91b18-32dc-43bc-a9cc-2ff6f82cb0e8" providerId="AD" clId="Web-{7573E014-B2A5-ACA1-AE5F-33998E947EDA}"/>
+    <pc:chgData name="KRASIC Srdjan (OP-EXT)" userId="S::srdjan.krasic@ext.ec.europa.eu::6da91b18-32dc-43bc-a9cc-2ff6f82cb0e8" providerId="AD" clId="Web-{F2D09C8A-C3C9-240F-AFB5-1EF866F36FEA}"/>
     <pc:docChg chg="modSld">
-      <pc:chgData name="KRASIC Srdjan (OP-EXT)" userId="S::srdjan.krasic@ext.ec.europa.eu::6da91b18-32dc-43bc-a9cc-2ff6f82cb0e8" providerId="AD" clId="Web-{7573E014-B2A5-ACA1-AE5F-33998E947EDA}" dt="2026-05-19T16:26:17.200" v="29" actId="20577"/>
+      <pc:chgData name="KRASIC Srdjan (OP-EXT)" userId="S::srdjan.krasic@ext.ec.europa.eu::6da91b18-32dc-43bc-a9cc-2ff6f82cb0e8" providerId="AD" clId="Web-{F2D09C8A-C3C9-240F-AFB5-1EF866F36FEA}" dt="2026-05-29T11:34:06.593" v="196" actId="20577"/>
       <pc:docMkLst>
         <pc:docMk/>
       </pc:docMkLst>
       <pc:sldChg chg="modSp">
-        <pc:chgData name="KRASIC Srdjan (OP-EXT)" userId="S::srdjan.krasic@ext.ec.europa.eu::6da91b18-32dc-43bc-a9cc-2ff6f82cb0e8" providerId="AD" clId="Web-{7573E014-B2A5-ACA1-AE5F-33998E947EDA}" dt="2026-05-19T16:26:17.200" v="29" actId="20577"/>
+        <pc:chgData name="KRASIC Srdjan (OP-EXT)" userId="S::srdjan.krasic@ext.ec.europa.eu::6da91b18-32dc-43bc-a9cc-2ff6f82cb0e8" providerId="AD" clId="Web-{F2D09C8A-C3C9-240F-AFB5-1EF866F36FEA}" dt="2026-05-29T11:28:48.100" v="177" actId="20577"/>
         <pc:sldMkLst>
           <pc:docMk/>
-          <pc:sldMk cId="981817496" sldId="1400"/>
+          <pc:sldMk cId="3777327881" sldId="259"/>
         </pc:sldMkLst>
         <pc:spChg chg="mod">
-          <ac:chgData name="KRASIC Srdjan (OP-EXT)" userId="S::srdjan.krasic@ext.ec.europa.eu::6da91b18-32dc-43bc-a9cc-2ff6f82cb0e8" providerId="AD" clId="Web-{7573E014-B2A5-ACA1-AE5F-33998E947EDA}" dt="2026-05-19T16:26:17.200" v="29" actId="20577"/>
+          <ac:chgData name="KRASIC Srdjan (OP-EXT)" userId="S::srdjan.krasic@ext.ec.europa.eu::6da91b18-32dc-43bc-a9cc-2ff6f82cb0e8" providerId="AD" clId="Web-{F2D09C8A-C3C9-240F-AFB5-1EF866F36FEA}" dt="2026-05-29T11:28:48.100" v="177" actId="20577"/>
           <ac:spMkLst>
             <pc:docMk/>
-            <pc:sldMk cId="981817496" sldId="1400"/>
-            <ac:spMk id="2" creationId="{C8B0B79D-8B76-5991-74F0-A1D95062DDAF}"/>
+            <pc:sldMk cId="3777327881" sldId="259"/>
+            <ac:spMk id="3" creationId="{C76EEE32-05B1-3943-B6B7-F172254DA883}"/>
           </ac:spMkLst>
         </pc:spChg>
-        <pc:graphicFrameChg chg="mod modGraphic">
-          <ac:chgData name="KRASIC Srdjan (OP-EXT)" userId="S::srdjan.krasic@ext.ec.europa.eu::6da91b18-32dc-43bc-a9cc-2ff6f82cb0e8" providerId="AD" clId="Web-{7573E014-B2A5-ACA1-AE5F-33998E947EDA}" dt="2026-05-19T16:26:05.496" v="28"/>
-          <ac:graphicFrameMkLst>
-            <pc:docMk/>
-            <pc:sldMk cId="981817496" sldId="1400"/>
-            <ac:graphicFrameMk id="4" creationId="{42F66917-925C-88A0-2E14-9BC390E596EE}"/>
-          </ac:graphicFrameMkLst>
-        </pc:graphicFrameChg>
       </pc:sldChg>
-    </pc:docChg>
-  </pc:docChgLst>
-  <pc:docChgLst>
-    <pc:chgData name="DONOHOE Paul (OP-EXT)" userId="S::paul.donohoe@ext.publications.europa.eu::c9df9133-e9aa-401a-a047-69aff1aabaa4" providerId="AD" clId="Web-{079B62D3-76F7-C8C1-3E52-3AC4AE09F1AB}"/>
-    <pc:docChg chg="addSld delSld modSld modSection">
-      <pc:chgData name="DONOHOE Paul (OP-EXT)" userId="S::paul.donohoe@ext.publications.europa.eu::c9df9133-e9aa-401a-a047-69aff1aabaa4" providerId="AD" clId="Web-{079B62D3-76F7-C8C1-3E52-3AC4AE09F1AB}" dt="2026-05-22T12:55:25.256" v="131" actId="20577"/>
-      <pc:docMkLst>
-        <pc:docMk/>
-      </pc:docMkLst>
       <pc:sldChg chg="modSp">
-        <pc:chgData name="DONOHOE Paul (OP-EXT)" userId="S::paul.donohoe@ext.publications.europa.eu::c9df9133-e9aa-401a-a047-69aff1aabaa4" providerId="AD" clId="Web-{079B62D3-76F7-C8C1-3E52-3AC4AE09F1AB}" dt="2026-05-22T12:52:03.014" v="55" actId="20577"/>
+        <pc:chgData name="KRASIC Srdjan (OP-EXT)" userId="S::srdjan.krasic@ext.ec.europa.eu::6da91b18-32dc-43bc-a9cc-2ff6f82cb0e8" providerId="AD" clId="Web-{F2D09C8A-C3C9-240F-AFB5-1EF866F36FEA}" dt="2026-05-29T11:34:06.593" v="196" actId="20577"/>
         <pc:sldMkLst>
           <pc:docMk/>
           <pc:sldMk cId="2419242855" sldId="1403"/>
         </pc:sldMkLst>
         <pc:spChg chg="mod">
-          <ac:chgData name="DONOHOE Paul (OP-EXT)" userId="S::paul.donohoe@ext.publications.europa.eu::c9df9133-e9aa-401a-a047-69aff1aabaa4" providerId="AD" clId="Web-{079B62D3-76F7-C8C1-3E52-3AC4AE09F1AB}" dt="2026-05-22T12:52:03.014" v="55" actId="20577"/>
-          <ac:spMkLst>
-            <pc:docMk/>
-            <pc:sldMk cId="2419242855" sldId="1403"/>
-            <ac:spMk id="3" creationId="{C76EEE32-05B1-3943-B6B7-F172254DA883}"/>
-          </ac:spMkLst>
-        </pc:spChg>
-      </pc:sldChg>
-      <pc:sldChg chg="modSp">
-        <pc:chgData name="DONOHOE Paul (OP-EXT)" userId="S::paul.donohoe@ext.publications.europa.eu::c9df9133-e9aa-401a-a047-69aff1aabaa4" providerId="AD" clId="Web-{079B62D3-76F7-C8C1-3E52-3AC4AE09F1AB}" dt="2026-05-22T11:31:19.688" v="52" actId="20577"/>
-        <pc:sldMkLst>
-          <pc:docMk/>
-          <pc:sldMk cId="3700328532" sldId="1408"/>
-        </pc:sldMkLst>
-        <pc:spChg chg="mod">
-          <ac:chgData name="DONOHOE Paul (OP-EXT)" userId="S::paul.donohoe@ext.publications.europa.eu::c9df9133-e9aa-401a-a047-69aff1aabaa4" providerId="AD" clId="Web-{079B62D3-76F7-C8C1-3E52-3AC4AE09F1AB}" dt="2026-05-22T11:31:19.688" v="52" actId="20577"/>
-          <ac:spMkLst>
-            <pc:docMk/>
-            <pc:sldMk cId="3700328532" sldId="1408"/>
-            <ac:spMk id="3" creationId="{93CE2629-F9EF-7A93-FD2C-D3730294CEAF}"/>
-          </ac:spMkLst>
-        </pc:spChg>
-      </pc:sldChg>
-      <pc:sldChg chg="addSp delSp modSp">
-        <pc:chgData name="DONOHOE Paul (OP-EXT)" userId="S::paul.donohoe@ext.publications.europa.eu::c9df9133-e9aa-401a-a047-69aff1aabaa4" providerId="AD" clId="Web-{079B62D3-76F7-C8C1-3E52-3AC4AE09F1AB}" dt="2026-05-22T12:55:25.256" v="131" actId="20577"/>
-        <pc:sldMkLst>
-          <pc:docMk/>
-          <pc:sldMk cId="1855452888" sldId="1422"/>
-        </pc:sldMkLst>
-        <pc:spChg chg="mod">
-          <ac:chgData name="DONOHOE Paul (OP-EXT)" userId="S::paul.donohoe@ext.publications.europa.eu::c9df9133-e9aa-401a-a047-69aff1aabaa4" providerId="AD" clId="Web-{079B62D3-76F7-C8C1-3E52-3AC4AE09F1AB}" dt="2026-05-22T12:55:25.256" v="131" actId="20577"/>
-          <ac:spMkLst>
-            <pc:docMk/>
-            <pc:sldMk cId="1855452888" sldId="1422"/>
-            <ac:spMk id="3" creationId="{7D8A9BDB-FDA7-B411-4B96-2E9F57CB57E2}"/>
-          </ac:spMkLst>
-        </pc:spChg>
-      </pc:sldChg>
-    </pc:docChg>
-  </pc:docChgLst>
-  <pc:docChgLst>
-    <pc:chgData name="KRASIC Srdjan (OP-EXT)" userId="S::srdjan.krasic@ext.ec.europa.eu::6da91b18-32dc-43bc-a9cc-2ff6f82cb0e8" providerId="AD" clId="Web-{04A35765-5453-51E5-461D-A8E7C1D44C07}"/>
-    <pc:docChg chg="modSld">
-      <pc:chgData name="KRASIC Srdjan (OP-EXT)" userId="S::srdjan.krasic@ext.ec.europa.eu::6da91b18-32dc-43bc-a9cc-2ff6f82cb0e8" providerId="AD" clId="Web-{04A35765-5453-51E5-461D-A8E7C1D44C07}" dt="2026-06-08T19:43:52.271" v="65" actId="20577"/>
-      <pc:docMkLst>
-        <pc:docMk/>
-      </pc:docMkLst>
-      <pc:sldChg chg="modSp">
-        <pc:chgData name="KRASIC Srdjan (OP-EXT)" userId="S::srdjan.krasic@ext.ec.europa.eu::6da91b18-32dc-43bc-a9cc-2ff6f82cb0e8" providerId="AD" clId="Web-{04A35765-5453-51E5-461D-A8E7C1D44C07}" dt="2026-06-08T19:43:52.271" v="65" actId="20577"/>
-        <pc:sldMkLst>
-          <pc:docMk/>
-          <pc:sldMk cId="2419242855" sldId="1403"/>
-        </pc:sldMkLst>
-        <pc:spChg chg="mod">
-          <ac:chgData name="KRASIC Srdjan (OP-EXT)" userId="S::srdjan.krasic@ext.ec.europa.eu::6da91b18-32dc-43bc-a9cc-2ff6f82cb0e8" providerId="AD" clId="Web-{04A35765-5453-51E5-461D-A8E7C1D44C07}" dt="2026-06-08T19:43:52.271" v="65" actId="20577"/>
+          <ac:chgData name="KRASIC Srdjan (OP-EXT)" userId="S::srdjan.krasic@ext.ec.europa.eu::6da91b18-32dc-43bc-a9cc-2ff6f82cb0e8" providerId="AD" clId="Web-{F2D09C8A-C3C9-240F-AFB5-1EF866F36FEA}" dt="2026-05-29T11:34:06.593" v="196" actId="20577"/>
           <ac:spMkLst>
             <pc:docMk/>
             <pc:sldMk cId="2419242855" sldId="1403"/>
@@ -889,71 +1264,28 @@
     </pc:docChg>
   </pc:docChgLst>
   <pc:docChgLst>
-    <pc:chgData name="DONOHOE Paul (OP-EXT)" userId="S::paul.donohoe@ext.publications.europa.eu::c9df9133-e9aa-401a-a047-69aff1aabaa4" providerId="AD" clId="Web-{E0019F40-253B-B092-9B57-6C27EB784B89}"/>
-    <pc:docChg chg="modSld sldOrd">
-      <pc:chgData name="DONOHOE Paul (OP-EXT)" userId="S::paul.donohoe@ext.publications.europa.eu::c9df9133-e9aa-401a-a047-69aff1aabaa4" providerId="AD" clId="Web-{E0019F40-253B-B092-9B57-6C27EB784B89}" dt="2026-06-09T08:39:03.392" v="4" actId="20577"/>
-      <pc:docMkLst>
-        <pc:docMk/>
-      </pc:docMkLst>
-      <pc:sldChg chg="ord">
-        <pc:chgData name="DONOHOE Paul (OP-EXT)" userId="S::paul.donohoe@ext.publications.europa.eu::c9df9133-e9aa-401a-a047-69aff1aabaa4" providerId="AD" clId="Web-{E0019F40-253B-B092-9B57-6C27EB784B89}" dt="2026-06-09T08:36:00.494" v="0"/>
-        <pc:sldMkLst>
-          <pc:docMk/>
-          <pc:sldMk cId="3654597332" sldId="1418"/>
-        </pc:sldMkLst>
-      </pc:sldChg>
-      <pc:sldChg chg="modSp modCm">
-        <pc:chgData name="DONOHOE Paul (OP-EXT)" userId="S::paul.donohoe@ext.publications.europa.eu::c9df9133-e9aa-401a-a047-69aff1aabaa4" providerId="AD" clId="Web-{E0019F40-253B-B092-9B57-6C27EB784B89}" dt="2026-06-09T08:39:03.392" v="4" actId="20577"/>
-        <pc:sldMkLst>
-          <pc:docMk/>
-          <pc:sldMk cId="1849753633" sldId="1419"/>
-        </pc:sldMkLst>
-        <pc:spChg chg="mod">
-          <ac:chgData name="DONOHOE Paul (OP-EXT)" userId="S::paul.donohoe@ext.publications.europa.eu::c9df9133-e9aa-401a-a047-69aff1aabaa4" providerId="AD" clId="Web-{E0019F40-253B-B092-9B57-6C27EB784B89}" dt="2026-06-09T08:39:03.392" v="4" actId="20577"/>
-          <ac:spMkLst>
-            <pc:docMk/>
-            <pc:sldMk cId="1849753633" sldId="1419"/>
-            <ac:spMk id="5" creationId="{6441FC53-4908-2481-AD2C-6F5024EF432F}"/>
-          </ac:spMkLst>
-        </pc:spChg>
-        <pc:extLst>
-          <p:ext xmlns:p="http://schemas.openxmlformats.org/presentationml/2006/main" uri="{D6D511B9-2390-475A-947B-AFAB55BFBCF1}">
-            <pc226:cmChg xmlns:pc226="http://schemas.microsoft.com/office/powerpoint/2022/06/main/command" chg="mod">
-              <pc226:chgData name="DONOHOE Paul (OP-EXT)" userId="S::paul.donohoe@ext.publications.europa.eu::c9df9133-e9aa-401a-a047-69aff1aabaa4" providerId="AD" clId="Web-{E0019F40-253B-B092-9B57-6C27EB784B89}" dt="2026-06-09T08:39:03.392" v="4" actId="20577"/>
-              <pc2:cmMkLst xmlns:pc2="http://schemas.microsoft.com/office/powerpoint/2019/9/main/command">
-                <pc:docMk/>
-                <pc:sldMk cId="1849753633" sldId="1419"/>
-                <pc2:cmMk id="{78C6353A-5ACB-4BA4-BAC1-08708F57B30C}"/>
-              </pc2:cmMkLst>
-            </pc226:cmChg>
-            <pc226:cmChg xmlns:pc226="http://schemas.microsoft.com/office/powerpoint/2022/06/main/command" chg="mod">
-              <pc226:chgData name="DONOHOE Paul (OP-EXT)" userId="S::paul.donohoe@ext.publications.europa.eu::c9df9133-e9aa-401a-a047-69aff1aabaa4" providerId="AD" clId="Web-{E0019F40-253B-B092-9B57-6C27EB784B89}" dt="2026-06-09T08:39:03.392" v="4" actId="20577"/>
-              <pc2:cmMkLst xmlns:pc2="http://schemas.microsoft.com/office/powerpoint/2019/9/main/command">
-                <pc:docMk/>
-                <pc:sldMk cId="1849753633" sldId="1419"/>
-                <pc2:cmMk id="{68AE4B65-1292-4296-8442-41C1DE84C894}"/>
-              </pc2:cmMkLst>
-            </pc226:cmChg>
-          </p:ext>
-        </pc:extLst>
-      </pc:sldChg>
-    </pc:docChg>
-  </pc:docChgLst>
-  <pc:docChgLst>
-    <pc:chgData name="KRASIC Srdjan (OP-EXT)" userId="S::srdjan.krasic@ext.ec.europa.eu::6da91b18-32dc-43bc-a9cc-2ff6f82cb0e8" providerId="AD" clId="Web-{D70C1FEB-295E-8F8B-383E-4E4563ABA334}"/>
+    <pc:chgData name="KRASIC Srdjan (OP-EXT)" userId="S::srdjan.krasic@ext.ec.europa.eu::6da91b18-32dc-43bc-a9cc-2ff6f82cb0e8" providerId="AD" clId="Web-{D6821814-B061-9325-684D-1513CB072418}"/>
     <pc:docChg chg="modSld">
-      <pc:chgData name="KRASIC Srdjan (OP-EXT)" userId="S::srdjan.krasic@ext.ec.europa.eu::6da91b18-32dc-43bc-a9cc-2ff6f82cb0e8" providerId="AD" clId="Web-{D70C1FEB-295E-8F8B-383E-4E4563ABA334}" dt="2026-06-09T13:10:35.813" v="6" actId="20577"/>
+      <pc:chgData name="KRASIC Srdjan (OP-EXT)" userId="S::srdjan.krasic@ext.ec.europa.eu::6da91b18-32dc-43bc-a9cc-2ff6f82cb0e8" providerId="AD" clId="Web-{D6821814-B061-9325-684D-1513CB072418}" dt="2026-06-09T14:48:50.959" v="64" actId="20577"/>
       <pc:docMkLst>
         <pc:docMk/>
       </pc:docMkLst>
       <pc:sldChg chg="modSp">
-        <pc:chgData name="KRASIC Srdjan (OP-EXT)" userId="S::srdjan.krasic@ext.ec.europa.eu::6da91b18-32dc-43bc-a9cc-2ff6f82cb0e8" providerId="AD" clId="Web-{D70C1FEB-295E-8F8B-383E-4E4563ABA334}" dt="2026-06-09T13:10:35.813" v="6" actId="20577"/>
+        <pc:chgData name="KRASIC Srdjan (OP-EXT)" userId="S::srdjan.krasic@ext.ec.europa.eu::6da91b18-32dc-43bc-a9cc-2ff6f82cb0e8" providerId="AD" clId="Web-{D6821814-B061-9325-684D-1513CB072418}" dt="2026-06-09T14:41:10.473" v="27" actId="20577"/>
         <pc:sldMkLst>
           <pc:docMk/>
           <pc:sldMk cId="3777327881" sldId="259"/>
         </pc:sldMkLst>
         <pc:spChg chg="mod">
-          <ac:chgData name="KRASIC Srdjan (OP-EXT)" userId="S::srdjan.krasic@ext.ec.europa.eu::6da91b18-32dc-43bc-a9cc-2ff6f82cb0e8" providerId="AD" clId="Web-{D70C1FEB-295E-8F8B-383E-4E4563ABA334}" dt="2026-06-09T13:10:35.813" v="6" actId="20577"/>
+          <ac:chgData name="KRASIC Srdjan (OP-EXT)" userId="S::srdjan.krasic@ext.ec.europa.eu::6da91b18-32dc-43bc-a9cc-2ff6f82cb0e8" providerId="AD" clId="Web-{D6821814-B061-9325-684D-1513CB072418}" dt="2026-06-09T14:41:10.473" v="27" actId="20577"/>
+          <ac:spMkLst>
+            <pc:docMk/>
+            <pc:sldMk cId="3777327881" sldId="259"/>
+            <ac:spMk id="3" creationId="{C76EEE32-05B1-3943-B6B7-F172254DA883}"/>
+          </ac:spMkLst>
+        </pc:spChg>
+        <pc:spChg chg="mod">
+          <ac:chgData name="KRASIC Srdjan (OP-EXT)" userId="S::srdjan.krasic@ext.ec.europa.eu::6da91b18-32dc-43bc-a9cc-2ff6f82cb0e8" providerId="AD" clId="Web-{D6821814-B061-9325-684D-1513CB072418}" dt="2026-06-09T14:37:39.028" v="1" actId="20577"/>
           <ac:spMkLst>
             <pc:docMk/>
             <pc:sldMk cId="3777327881" sldId="259"/>
@@ -961,44 +1293,75 @@
           </ac:spMkLst>
         </pc:spChg>
       </pc:sldChg>
+      <pc:sldChg chg="modSp">
+        <pc:chgData name="KRASIC Srdjan (OP-EXT)" userId="S::srdjan.krasic@ext.ec.europa.eu::6da91b18-32dc-43bc-a9cc-2ff6f82cb0e8" providerId="AD" clId="Web-{D6821814-B061-9325-684D-1513CB072418}" dt="2026-06-09T14:48:50.959" v="64" actId="20577"/>
+        <pc:sldMkLst>
+          <pc:docMk/>
+          <pc:sldMk cId="2419242855" sldId="1403"/>
+        </pc:sldMkLst>
+        <pc:spChg chg="mod">
+          <ac:chgData name="KRASIC Srdjan (OP-EXT)" userId="S::srdjan.krasic@ext.ec.europa.eu::6da91b18-32dc-43bc-a9cc-2ff6f82cb0e8" providerId="AD" clId="Web-{D6821814-B061-9325-684D-1513CB072418}" dt="2026-06-09T14:48:50.959" v="64" actId="20577"/>
+          <ac:spMkLst>
+            <pc:docMk/>
+            <pc:sldMk cId="2419242855" sldId="1403"/>
+            <ac:spMk id="3" creationId="{C76EEE32-05B1-3943-B6B7-F172254DA883}"/>
+          </ac:spMkLst>
+        </pc:spChg>
+      </pc:sldChg>
+      <pc:sldChg chg="modSp">
+        <pc:chgData name="KRASIC Srdjan (OP-EXT)" userId="S::srdjan.krasic@ext.ec.europa.eu::6da91b18-32dc-43bc-a9cc-2ff6f82cb0e8" providerId="AD" clId="Web-{D6821814-B061-9325-684D-1513CB072418}" dt="2026-06-09T14:45:08.576" v="29" actId="20577"/>
+        <pc:sldMkLst>
+          <pc:docMk/>
+          <pc:sldMk cId="3700328532" sldId="1408"/>
+        </pc:sldMkLst>
+        <pc:spChg chg="mod">
+          <ac:chgData name="KRASIC Srdjan (OP-EXT)" userId="S::srdjan.krasic@ext.ec.europa.eu::6da91b18-32dc-43bc-a9cc-2ff6f82cb0e8" providerId="AD" clId="Web-{D6821814-B061-9325-684D-1513CB072418}" dt="2026-06-09T14:45:08.576" v="29" actId="20577"/>
+          <ac:spMkLst>
+            <pc:docMk/>
+            <pc:sldMk cId="3700328532" sldId="1408"/>
+            <ac:spMk id="3" creationId="{93CE2629-F9EF-7A93-FD2C-D3730294CEAF}"/>
+          </ac:spMkLst>
+        </pc:spChg>
+      </pc:sldChg>
     </pc:docChg>
   </pc:docChgLst>
   <pc:docChgLst>
-    <pc:chgData name="YFANTI Sevasti (OP-EXT)" userId="S::sevasti.yfanti@ext.ec.europa.eu::7c42bec1-26c8-4f31-ac03-7337768c55f5" providerId="AD" clId="Web-{BE359CB9-F3B2-7C44-DA59-701EA4C9D921}"/>
+    <pc:chgData name="YFANTI Sevasti (OP-EXT)" userId="S::sevasti.yfanti@ext.ec.europa.eu::7c42bec1-26c8-4f31-ac03-7337768c55f5" providerId="AD" clId="Web-{60405500-956F-AB26-A918-8A2BD6DC9882}"/>
     <pc:docChg chg="modSld">
-      <pc:chgData name="YFANTI Sevasti (OP-EXT)" userId="S::sevasti.yfanti@ext.ec.europa.eu::7c42bec1-26c8-4f31-ac03-7337768c55f5" providerId="AD" clId="Web-{BE359CB9-F3B2-7C44-DA59-701EA4C9D921}" dt="2026-05-26T14:22:09.559" v="105" actId="20577"/>
+      <pc:chgData name="YFANTI Sevasti (OP-EXT)" userId="S::sevasti.yfanti@ext.ec.europa.eu::7c42bec1-26c8-4f31-ac03-7337768c55f5" providerId="AD" clId="Web-{60405500-956F-AB26-A918-8A2BD6DC9882}" dt="2026-06-09T10:40:11.169" v="2" actId="1076"/>
       <pc:docMkLst>
         <pc:docMk/>
       </pc:docMkLst>
-      <pc:sldChg chg="modSp">
-        <pc:chgData name="YFANTI Sevasti (OP-EXT)" userId="S::sevasti.yfanti@ext.ec.europa.eu::7c42bec1-26c8-4f31-ac03-7337768c55f5" providerId="AD" clId="Web-{BE359CB9-F3B2-7C44-DA59-701EA4C9D921}" dt="2026-05-26T14:16:45.725" v="5" actId="20577"/>
+      <pc:sldChg chg="addSp delSp modSp">
+        <pc:chgData name="YFANTI Sevasti (OP-EXT)" userId="S::sevasti.yfanti@ext.ec.europa.eu::7c42bec1-26c8-4f31-ac03-7337768c55f5" providerId="AD" clId="Web-{60405500-956F-AB26-A918-8A2BD6DC9882}" dt="2026-06-09T10:40:11.169" v="2" actId="1076"/>
         <pc:sldMkLst>
           <pc:docMk/>
           <pc:sldMk cId="1360176188" sldId="1420"/>
         </pc:sldMkLst>
-        <pc:spChg chg="mod">
-          <ac:chgData name="YFANTI Sevasti (OP-EXT)" userId="S::sevasti.yfanti@ext.ec.europa.eu::7c42bec1-26c8-4f31-ac03-7337768c55f5" providerId="AD" clId="Web-{BE359CB9-F3B2-7C44-DA59-701EA4C9D921}" dt="2026-05-26T14:16:45.725" v="5" actId="20577"/>
+        <pc:spChg chg="add del mod">
+          <ac:chgData name="YFANTI Sevasti (OP-EXT)" userId="S::sevasti.yfanti@ext.ec.europa.eu::7c42bec1-26c8-4f31-ac03-7337768c55f5" providerId="AD" clId="Web-{60405500-956F-AB26-A918-8A2BD6DC9882}" dt="2026-06-09T10:40:08.060" v="1"/>
           <ac:spMkLst>
             <pc:docMk/>
             <pc:sldMk cId="1360176188" sldId="1420"/>
-            <ac:spMk id="9" creationId="{4DFC0EF3-9841-0744-6F72-CB5E722CE34B}"/>
+            <ac:spMk id="6" creationId="{9C29324B-7559-9556-DEB0-2C0D17EA7BB0}"/>
           </ac:spMkLst>
         </pc:spChg>
-      </pc:sldChg>
-      <pc:sldChg chg="modSp">
-        <pc:chgData name="YFANTI Sevasti (OP-EXT)" userId="S::sevasti.yfanti@ext.ec.europa.eu::7c42bec1-26c8-4f31-ac03-7337768c55f5" providerId="AD" clId="Web-{BE359CB9-F3B2-7C44-DA59-701EA4C9D921}" dt="2026-05-26T14:22:09.559" v="105" actId="20577"/>
-        <pc:sldMkLst>
-          <pc:docMk/>
-          <pc:sldMk cId="194845558" sldId="1421"/>
-        </pc:sldMkLst>
-        <pc:spChg chg="mod">
-          <ac:chgData name="YFANTI Sevasti (OP-EXT)" userId="S::sevasti.yfanti@ext.ec.europa.eu::7c42bec1-26c8-4f31-ac03-7337768c55f5" providerId="AD" clId="Web-{BE359CB9-F3B2-7C44-DA59-701EA4C9D921}" dt="2026-05-26T14:22:09.559" v="105" actId="20577"/>
-          <ac:spMkLst>
+        <pc:picChg chg="del">
+          <ac:chgData name="YFANTI Sevasti (OP-EXT)" userId="S::sevasti.yfanti@ext.ec.europa.eu::7c42bec1-26c8-4f31-ac03-7337768c55f5" providerId="AD" clId="Web-{60405500-956F-AB26-A918-8A2BD6DC9882}" dt="2026-06-09T10:40:03.778" v="0"/>
+          <ac:picMkLst>
             <pc:docMk/>
-            <pc:sldMk cId="194845558" sldId="1421"/>
-            <ac:spMk id="4" creationId="{AC195AC9-43A6-048B-382D-618B79F10F7F}"/>
-          </ac:spMkLst>
-        </pc:spChg>
+            <pc:sldMk cId="1360176188" sldId="1420"/>
+            <ac:picMk id="7" creationId="{D1EDFD0B-61FB-C5A4-1E7F-02A58AED84D3}"/>
+          </ac:picMkLst>
+        </pc:picChg>
+        <pc:picChg chg="add mod ord">
+          <ac:chgData name="YFANTI Sevasti (OP-EXT)" userId="S::sevasti.yfanti@ext.ec.europa.eu::7c42bec1-26c8-4f31-ac03-7337768c55f5" providerId="AD" clId="Web-{60405500-956F-AB26-A918-8A2BD6DC9882}" dt="2026-06-09T10:40:11.169" v="2" actId="1076"/>
+          <ac:picMkLst>
+            <pc:docMk/>
+            <pc:sldMk cId="1360176188" sldId="1420"/>
+            <ac:picMk id="8" creationId="{85F46BA3-E327-7B18-BA56-9099F17828F4}"/>
+          </ac:picMkLst>
+        </pc:picChg>
       </pc:sldChg>
     </pc:docChg>
   </pc:docChgLst>
@@ -1063,369 +1426,6 @@
       </pc:sldChg>
     </pc:docChg>
   </pc:docChgLst>
-  <pc:docChgLst>
-    <pc:chgData name="KRASIC Srdjan (OP-EXT)" userId="S::srdjan.krasic@ext.ec.europa.eu::6da91b18-32dc-43bc-a9cc-2ff6f82cb0e8" providerId="AD" clId="Web-{A8406028-A772-858E-35E4-918BBF61E412}"/>
-    <pc:docChg chg="addSld modSld sldOrd modSection">
-      <pc:chgData name="KRASIC Srdjan (OP-EXT)" userId="S::srdjan.krasic@ext.ec.europa.eu::6da91b18-32dc-43bc-a9cc-2ff6f82cb0e8" providerId="AD" clId="Web-{A8406028-A772-858E-35E4-918BBF61E412}" dt="2026-05-21T14:16:06.636" v="145" actId="20577"/>
-      <pc:docMkLst>
-        <pc:docMk/>
-      </pc:docMkLst>
-      <pc:sldChg chg="modSp">
-        <pc:chgData name="KRASIC Srdjan (OP-EXT)" userId="S::srdjan.krasic@ext.ec.europa.eu::6da91b18-32dc-43bc-a9cc-2ff6f82cb0e8" providerId="AD" clId="Web-{A8406028-A772-858E-35E4-918BBF61E412}" dt="2026-05-21T14:04:09.944" v="115" actId="20577"/>
-        <pc:sldMkLst>
-          <pc:docMk/>
-          <pc:sldMk cId="255292099" sldId="258"/>
-        </pc:sldMkLst>
-        <pc:spChg chg="mod">
-          <ac:chgData name="KRASIC Srdjan (OP-EXT)" userId="S::srdjan.krasic@ext.ec.europa.eu::6da91b18-32dc-43bc-a9cc-2ff6f82cb0e8" providerId="AD" clId="Web-{A8406028-A772-858E-35E4-918BBF61E412}" dt="2026-05-21T14:04:09.944" v="115" actId="20577"/>
-          <ac:spMkLst>
-            <pc:docMk/>
-            <pc:sldMk cId="255292099" sldId="258"/>
-            <ac:spMk id="9" creationId="{67AD3164-9F40-E8FE-4B28-F9581136DD43}"/>
-          </ac:spMkLst>
-        </pc:spChg>
-      </pc:sldChg>
-      <pc:sldChg chg="modSp">
-        <pc:chgData name="KRASIC Srdjan (OP-EXT)" userId="S::srdjan.krasic@ext.ec.europa.eu::6da91b18-32dc-43bc-a9cc-2ff6f82cb0e8" providerId="AD" clId="Web-{A8406028-A772-858E-35E4-918BBF61E412}" dt="2026-05-21T13:39:33.552" v="17"/>
-        <pc:sldMkLst>
-          <pc:docMk/>
-          <pc:sldMk cId="981817496" sldId="1400"/>
-        </pc:sldMkLst>
-        <pc:graphicFrameChg chg="mod modGraphic">
-          <ac:chgData name="KRASIC Srdjan (OP-EXT)" userId="S::srdjan.krasic@ext.ec.europa.eu::6da91b18-32dc-43bc-a9cc-2ff6f82cb0e8" providerId="AD" clId="Web-{A8406028-A772-858E-35E4-918BBF61E412}" dt="2026-05-21T13:39:33.552" v="17"/>
-          <ac:graphicFrameMkLst>
-            <pc:docMk/>
-            <pc:sldMk cId="981817496" sldId="1400"/>
-            <ac:graphicFrameMk id="4" creationId="{42F66917-925C-88A0-2E14-9BC390E596EE}"/>
-          </ac:graphicFrameMkLst>
-        </pc:graphicFrameChg>
-      </pc:sldChg>
-      <pc:sldChg chg="modSp">
-        <pc:chgData name="KRASIC Srdjan (OP-EXT)" userId="S::srdjan.krasic@ext.ec.europa.eu::6da91b18-32dc-43bc-a9cc-2ff6f82cb0e8" providerId="AD" clId="Web-{A8406028-A772-858E-35E4-918BBF61E412}" dt="2026-05-21T14:16:06.636" v="145" actId="20577"/>
-        <pc:sldMkLst>
-          <pc:docMk/>
-          <pc:sldMk cId="2419242855" sldId="1403"/>
-        </pc:sldMkLst>
-        <pc:spChg chg="mod">
-          <ac:chgData name="KRASIC Srdjan (OP-EXT)" userId="S::srdjan.krasic@ext.ec.europa.eu::6da91b18-32dc-43bc-a9cc-2ff6f82cb0e8" providerId="AD" clId="Web-{A8406028-A772-858E-35E4-918BBF61E412}" dt="2026-05-21T14:05:04.163" v="117" actId="20577"/>
-          <ac:spMkLst>
-            <pc:docMk/>
-            <pc:sldMk cId="2419242855" sldId="1403"/>
-            <ac:spMk id="2" creationId="{F20262FE-51C3-9547-9ED8-C7F938F2B0AA}"/>
-          </ac:spMkLst>
-        </pc:spChg>
-        <pc:spChg chg="mod">
-          <ac:chgData name="KRASIC Srdjan (OP-EXT)" userId="S::srdjan.krasic@ext.ec.europa.eu::6da91b18-32dc-43bc-a9cc-2ff6f82cb0e8" providerId="AD" clId="Web-{A8406028-A772-858E-35E4-918BBF61E412}" dt="2026-05-21T14:16:06.636" v="145" actId="20577"/>
-          <ac:spMkLst>
-            <pc:docMk/>
-            <pc:sldMk cId="2419242855" sldId="1403"/>
-            <ac:spMk id="3" creationId="{C76EEE32-05B1-3943-B6B7-F172254DA883}"/>
-          </ac:spMkLst>
-        </pc:spChg>
-      </pc:sldChg>
-      <pc:sldChg chg="modSp">
-        <pc:chgData name="KRASIC Srdjan (OP-EXT)" userId="S::srdjan.krasic@ext.ec.europa.eu::6da91b18-32dc-43bc-a9cc-2ff6f82cb0e8" providerId="AD" clId="Web-{A8406028-A772-858E-35E4-918BBF61E412}" dt="2026-05-21T14:05:16.601" v="119" actId="20577"/>
-        <pc:sldMkLst>
-          <pc:docMk/>
-          <pc:sldMk cId="3700328532" sldId="1408"/>
-        </pc:sldMkLst>
-        <pc:spChg chg="mod">
-          <ac:chgData name="KRASIC Srdjan (OP-EXT)" userId="S::srdjan.krasic@ext.ec.europa.eu::6da91b18-32dc-43bc-a9cc-2ff6f82cb0e8" providerId="AD" clId="Web-{A8406028-A772-858E-35E4-918BBF61E412}" dt="2026-05-21T14:05:16.601" v="119" actId="20577"/>
-          <ac:spMkLst>
-            <pc:docMk/>
-            <pc:sldMk cId="3700328532" sldId="1408"/>
-            <ac:spMk id="2" creationId="{445F8046-0E9D-FCCE-E14C-F03BD8373AA3}"/>
-          </ac:spMkLst>
-        </pc:spChg>
-        <pc:spChg chg="mod">
-          <ac:chgData name="KRASIC Srdjan (OP-EXT)" userId="S::srdjan.krasic@ext.ec.europa.eu::6da91b18-32dc-43bc-a9cc-2ff6f82cb0e8" providerId="AD" clId="Web-{A8406028-A772-858E-35E4-918BBF61E412}" dt="2026-05-21T13:58:58.271" v="76" actId="20577"/>
-          <ac:spMkLst>
-            <pc:docMk/>
-            <pc:sldMk cId="3700328532" sldId="1408"/>
-            <ac:spMk id="3" creationId="{93CE2629-F9EF-7A93-FD2C-D3730294CEAF}"/>
-          </ac:spMkLst>
-        </pc:spChg>
-      </pc:sldChg>
-      <pc:sldChg chg="delSp modSp add ord replId">
-        <pc:chgData name="KRASIC Srdjan (OP-EXT)" userId="S::srdjan.krasic@ext.ec.europa.eu::6da91b18-32dc-43bc-a9cc-2ff6f82cb0e8" providerId="AD" clId="Web-{A8406028-A772-858E-35E4-918BBF61E412}" dt="2026-05-21T13:49:05.468" v="51" actId="20577"/>
-        <pc:sldMkLst>
-          <pc:docMk/>
-          <pc:sldMk cId="1855452888" sldId="1422"/>
-        </pc:sldMkLst>
-        <pc:spChg chg="mod">
-          <ac:chgData name="KRASIC Srdjan (OP-EXT)" userId="S::srdjan.krasic@ext.ec.europa.eu::6da91b18-32dc-43bc-a9cc-2ff6f82cb0e8" providerId="AD" clId="Web-{A8406028-A772-858E-35E4-918BBF61E412}" dt="2026-05-21T13:48:40.874" v="40" actId="20577"/>
-          <ac:spMkLst>
-            <pc:docMk/>
-            <pc:sldMk cId="1855452888" sldId="1422"/>
-            <ac:spMk id="2" creationId="{BBB4B94F-0613-388D-58C2-A94A8C0BE49E}"/>
-          </ac:spMkLst>
-        </pc:spChg>
-        <pc:spChg chg="mod">
-          <ac:chgData name="KRASIC Srdjan (OP-EXT)" userId="S::srdjan.krasic@ext.ec.europa.eu::6da91b18-32dc-43bc-a9cc-2ff6f82cb0e8" providerId="AD" clId="Web-{A8406028-A772-858E-35E4-918BBF61E412}" dt="2026-05-21T13:49:05.468" v="51" actId="20577"/>
-          <ac:spMkLst>
-            <pc:docMk/>
-            <pc:sldMk cId="1855452888" sldId="1422"/>
-            <ac:spMk id="3" creationId="{7D8A9BDB-FDA7-B411-4B96-2E9F57CB57E2}"/>
-          </ac:spMkLst>
-        </pc:spChg>
-      </pc:sldChg>
-    </pc:docChg>
-  </pc:docChgLst>
-  <pc:docChgLst>
-    <pc:chgData name="DONOHOE Paul (OP-EXT)" userId="S::paul.donohoe@ext.publications.europa.eu::c9df9133-e9aa-401a-a047-69aff1aabaa4" providerId="AD" clId="Web-{CA7D48B9-D6CB-8A7A-C251-630C823E82D8}"/>
-    <pc:docChg chg="modSld">
-      <pc:chgData name="DONOHOE Paul (OP-EXT)" userId="S::paul.donohoe@ext.publications.europa.eu::c9df9133-e9aa-401a-a047-69aff1aabaa4" providerId="AD" clId="Web-{CA7D48B9-D6CB-8A7A-C251-630C823E82D8}" dt="2026-06-01T07:57:16.108" v="79"/>
-      <pc:docMkLst>
-        <pc:docMk/>
-      </pc:docMkLst>
-      <pc:sldChg chg="modNotes">
-        <pc:chgData name="DONOHOE Paul (OP-EXT)" userId="S::paul.donohoe@ext.publications.europa.eu::c9df9133-e9aa-401a-a047-69aff1aabaa4" providerId="AD" clId="Web-{CA7D48B9-D6CB-8A7A-C251-630C823E82D8}" dt="2026-06-01T07:45:42.300" v="68"/>
-        <pc:sldMkLst>
-          <pc:docMk/>
-          <pc:sldMk cId="2699462789" sldId="1417"/>
-        </pc:sldMkLst>
-      </pc:sldChg>
-      <pc:sldChg chg="modNotes">
-        <pc:chgData name="DONOHOE Paul (OP-EXT)" userId="S::paul.donohoe@ext.publications.europa.eu::c9df9133-e9aa-401a-a047-69aff1aabaa4" providerId="AD" clId="Web-{CA7D48B9-D6CB-8A7A-C251-630C823E82D8}" dt="2026-06-01T07:55:58.621" v="72"/>
-        <pc:sldMkLst>
-          <pc:docMk/>
-          <pc:sldMk cId="3654597332" sldId="1418"/>
-        </pc:sldMkLst>
-      </pc:sldChg>
-      <pc:sldChg chg="modNotes">
-        <pc:chgData name="DONOHOE Paul (OP-EXT)" userId="S::paul.donohoe@ext.publications.europa.eu::c9df9133-e9aa-401a-a047-69aff1aabaa4" providerId="AD" clId="Web-{CA7D48B9-D6CB-8A7A-C251-630C823E82D8}" dt="2026-06-01T07:57:16.108" v="79"/>
-        <pc:sldMkLst>
-          <pc:docMk/>
-          <pc:sldMk cId="1849753633" sldId="1419"/>
-        </pc:sldMkLst>
-      </pc:sldChg>
-    </pc:docChg>
-  </pc:docChgLst>
-  <pc:docChgLst>
-    <pc:chgData name="DONOHOE Paul (OP-EXT)" userId="c9df9133-e9aa-401a-a047-69aff1aabaa4" providerId="ADAL" clId="{FF0E4331-F76A-49E2-AE24-5ABE3B435529}"/>
-    <pc:docChg chg="custSel modSld">
-      <pc:chgData name="DONOHOE Paul (OP-EXT)" userId="c9df9133-e9aa-401a-a047-69aff1aabaa4" providerId="ADAL" clId="{FF0E4331-F76A-49E2-AE24-5ABE3B435529}" dt="2026-06-09T11:52:40.505" v="290" actId="20577"/>
-      <pc:docMkLst>
-        <pc:docMk/>
-      </pc:docMkLst>
-      <pc:sldChg chg="modSp mod">
-        <pc:chgData name="DONOHOE Paul (OP-EXT)" userId="c9df9133-e9aa-401a-a047-69aff1aabaa4" providerId="ADAL" clId="{FF0E4331-F76A-49E2-AE24-5ABE3B435529}" dt="2026-06-09T09:34:16.903" v="52" actId="20577"/>
-        <pc:sldMkLst>
-          <pc:docMk/>
-          <pc:sldMk cId="2419242855" sldId="1403"/>
-        </pc:sldMkLst>
-        <pc:spChg chg="mod">
-          <ac:chgData name="DONOHOE Paul (OP-EXT)" userId="c9df9133-e9aa-401a-a047-69aff1aabaa4" providerId="ADAL" clId="{FF0E4331-F76A-49E2-AE24-5ABE3B435529}" dt="2026-06-09T09:34:16.903" v="52" actId="20577"/>
-          <ac:spMkLst>
-            <pc:docMk/>
-            <pc:sldMk cId="2419242855" sldId="1403"/>
-            <ac:spMk id="3" creationId="{C76EEE32-05B1-3943-B6B7-F172254DA883}"/>
-          </ac:spMkLst>
-        </pc:spChg>
-      </pc:sldChg>
-      <pc:sldChg chg="modNotesTx">
-        <pc:chgData name="DONOHOE Paul (OP-EXT)" userId="c9df9133-e9aa-401a-a047-69aff1aabaa4" providerId="ADAL" clId="{FF0E4331-F76A-49E2-AE24-5ABE3B435529}" dt="2026-06-09T11:52:40.505" v="290" actId="20577"/>
-        <pc:sldMkLst>
-          <pc:docMk/>
-          <pc:sldMk cId="3654597332" sldId="1418"/>
-        </pc:sldMkLst>
-      </pc:sldChg>
-    </pc:docChg>
-  </pc:docChgLst>
-  <pc:docChgLst>
-    <pc:chgData clId="Web-{A8406028-A772-858E-35E4-918BBF61E412}"/>
-    <pc:docChg chg="modSld">
-      <pc:chgData name="" userId="" providerId="" clId="Web-{A8406028-A772-858E-35E4-918BBF61E412}" dt="2026-05-21T13:49:11.986" v="0" actId="20577"/>
-      <pc:docMkLst>
-        <pc:docMk/>
-      </pc:docMkLst>
-      <pc:sldChg chg="modSp">
-        <pc:chgData name="" userId="" providerId="" clId="Web-{A8406028-A772-858E-35E4-918BBF61E412}" dt="2026-05-21T13:49:11.986" v="0" actId="20577"/>
-        <pc:sldMkLst>
-          <pc:docMk/>
-          <pc:sldMk cId="1855452888" sldId="1422"/>
-        </pc:sldMkLst>
-        <pc:spChg chg="mod">
-          <ac:chgData name="" userId="" providerId="" clId="Web-{A8406028-A772-858E-35E4-918BBF61E412}" dt="2026-05-21T13:49:11.986" v="0" actId="20577"/>
-          <ac:spMkLst>
-            <pc:docMk/>
-            <pc:sldMk cId="1855452888" sldId="1422"/>
-            <ac:spMk id="3" creationId="{7D8A9BDB-FDA7-B411-4B96-2E9F57CB57E2}"/>
-          </ac:spMkLst>
-        </pc:spChg>
-      </pc:sldChg>
-    </pc:docChg>
-  </pc:docChgLst>
-  <pc:docChgLst>
-    <pc:chgData name="KRASIC Srdjan (OP-EXT)" userId="S::srdjan.krasic@ext.ec.europa.eu::6da91b18-32dc-43bc-a9cc-2ff6f82cb0e8" providerId="AD" clId="Web-{F2D09C8A-C3C9-240F-AFB5-1EF866F36FEA}"/>
-    <pc:docChg chg="modSld">
-      <pc:chgData name="KRASIC Srdjan (OP-EXT)" userId="S::srdjan.krasic@ext.ec.europa.eu::6da91b18-32dc-43bc-a9cc-2ff6f82cb0e8" providerId="AD" clId="Web-{F2D09C8A-C3C9-240F-AFB5-1EF866F36FEA}" dt="2026-05-29T11:34:06.593" v="196" actId="20577"/>
-      <pc:docMkLst>
-        <pc:docMk/>
-      </pc:docMkLst>
-      <pc:sldChg chg="modSp">
-        <pc:chgData name="KRASIC Srdjan (OP-EXT)" userId="S::srdjan.krasic@ext.ec.europa.eu::6da91b18-32dc-43bc-a9cc-2ff6f82cb0e8" providerId="AD" clId="Web-{F2D09C8A-C3C9-240F-AFB5-1EF866F36FEA}" dt="2026-05-29T11:28:48.100" v="177" actId="20577"/>
-        <pc:sldMkLst>
-          <pc:docMk/>
-          <pc:sldMk cId="3777327881" sldId="259"/>
-        </pc:sldMkLst>
-        <pc:spChg chg="mod">
-          <ac:chgData name="KRASIC Srdjan (OP-EXT)" userId="S::srdjan.krasic@ext.ec.europa.eu::6da91b18-32dc-43bc-a9cc-2ff6f82cb0e8" providerId="AD" clId="Web-{F2D09C8A-C3C9-240F-AFB5-1EF866F36FEA}" dt="2026-05-29T11:28:48.100" v="177" actId="20577"/>
-          <ac:spMkLst>
-            <pc:docMk/>
-            <pc:sldMk cId="3777327881" sldId="259"/>
-            <ac:spMk id="3" creationId="{C76EEE32-05B1-3943-B6B7-F172254DA883}"/>
-          </ac:spMkLst>
-        </pc:spChg>
-      </pc:sldChg>
-      <pc:sldChg chg="modSp">
-        <pc:chgData name="KRASIC Srdjan (OP-EXT)" userId="S::srdjan.krasic@ext.ec.europa.eu::6da91b18-32dc-43bc-a9cc-2ff6f82cb0e8" providerId="AD" clId="Web-{F2D09C8A-C3C9-240F-AFB5-1EF866F36FEA}" dt="2026-05-29T11:34:06.593" v="196" actId="20577"/>
-        <pc:sldMkLst>
-          <pc:docMk/>
-          <pc:sldMk cId="2419242855" sldId="1403"/>
-        </pc:sldMkLst>
-        <pc:spChg chg="mod">
-          <ac:chgData name="KRASIC Srdjan (OP-EXT)" userId="S::srdjan.krasic@ext.ec.europa.eu::6da91b18-32dc-43bc-a9cc-2ff6f82cb0e8" providerId="AD" clId="Web-{F2D09C8A-C3C9-240F-AFB5-1EF866F36FEA}" dt="2026-05-29T11:34:06.593" v="196" actId="20577"/>
-          <ac:spMkLst>
-            <pc:docMk/>
-            <pc:sldMk cId="2419242855" sldId="1403"/>
-            <ac:spMk id="3" creationId="{C76EEE32-05B1-3943-B6B7-F172254DA883}"/>
-          </ac:spMkLst>
-        </pc:spChg>
-      </pc:sldChg>
-    </pc:docChg>
-  </pc:docChgLst>
-  <pc:docChgLst>
-    <pc:chgData name="KRASIC Srdjan (OP-EXT)" userId="S::srdjan.krasic@ext.ec.europa.eu::6da91b18-32dc-43bc-a9cc-2ff6f82cb0e8" providerId="AD" clId="Web-{EF396895-D3C6-4FE9-CA0B-9A5304DD48B9}"/>
-    <pc:docChg chg="modSld">
-      <pc:chgData name="KRASIC Srdjan (OP-EXT)" userId="S::srdjan.krasic@ext.ec.europa.eu::6da91b18-32dc-43bc-a9cc-2ff6f82cb0e8" providerId="AD" clId="Web-{EF396895-D3C6-4FE9-CA0B-9A5304DD48B9}" dt="2026-06-08T19:48:36.569" v="4" actId="20577"/>
-      <pc:docMkLst>
-        <pc:docMk/>
-      </pc:docMkLst>
-      <pc:sldChg chg="modSp">
-        <pc:chgData name="KRASIC Srdjan (OP-EXT)" userId="S::srdjan.krasic@ext.ec.europa.eu::6da91b18-32dc-43bc-a9cc-2ff6f82cb0e8" providerId="AD" clId="Web-{EF396895-D3C6-4FE9-CA0B-9A5304DD48B9}" dt="2026-06-08T19:47:55.019" v="0" actId="20577"/>
-        <pc:sldMkLst>
-          <pc:docMk/>
-          <pc:sldMk cId="2699462789" sldId="1417"/>
-        </pc:sldMkLst>
-        <pc:spChg chg="mod">
-          <ac:chgData name="KRASIC Srdjan (OP-EXT)" userId="S::srdjan.krasic@ext.ec.europa.eu::6da91b18-32dc-43bc-a9cc-2ff6f82cb0e8" providerId="AD" clId="Web-{EF396895-D3C6-4FE9-CA0B-9A5304DD48B9}" dt="2026-06-08T19:47:55.019" v="0" actId="20577"/>
-          <ac:spMkLst>
-            <pc:docMk/>
-            <pc:sldMk cId="2699462789" sldId="1417"/>
-            <ac:spMk id="2" creationId="{E50ADB50-3F58-336E-5BC6-335254A8877D}"/>
-          </ac:spMkLst>
-        </pc:spChg>
-      </pc:sldChg>
-      <pc:sldChg chg="modSp">
-        <pc:chgData name="KRASIC Srdjan (OP-EXT)" userId="S::srdjan.krasic@ext.ec.europa.eu::6da91b18-32dc-43bc-a9cc-2ff6f82cb0e8" providerId="AD" clId="Web-{EF396895-D3C6-4FE9-CA0B-9A5304DD48B9}" dt="2026-06-08T19:48:29.694" v="3" actId="20577"/>
-        <pc:sldMkLst>
-          <pc:docMk/>
-          <pc:sldMk cId="3654597332" sldId="1418"/>
-        </pc:sldMkLst>
-        <pc:spChg chg="mod">
-          <ac:chgData name="KRASIC Srdjan (OP-EXT)" userId="S::srdjan.krasic@ext.ec.europa.eu::6da91b18-32dc-43bc-a9cc-2ff6f82cb0e8" providerId="AD" clId="Web-{EF396895-D3C6-4FE9-CA0B-9A5304DD48B9}" dt="2026-06-08T19:48:29.694" v="3" actId="20577"/>
-          <ac:spMkLst>
-            <pc:docMk/>
-            <pc:sldMk cId="3654597332" sldId="1418"/>
-            <ac:spMk id="2" creationId="{D70C2FC5-1B46-B4E4-C31E-468AA17263D3}"/>
-          </ac:spMkLst>
-        </pc:spChg>
-      </pc:sldChg>
-      <pc:sldChg chg="modSp">
-        <pc:chgData name="KRASIC Srdjan (OP-EXT)" userId="S::srdjan.krasic@ext.ec.europa.eu::6da91b18-32dc-43bc-a9cc-2ff6f82cb0e8" providerId="AD" clId="Web-{EF396895-D3C6-4FE9-CA0B-9A5304DD48B9}" dt="2026-06-08T19:48:36.569" v="4" actId="20577"/>
-        <pc:sldMkLst>
-          <pc:docMk/>
-          <pc:sldMk cId="1849753633" sldId="1419"/>
-        </pc:sldMkLst>
-        <pc:spChg chg="mod">
-          <ac:chgData name="KRASIC Srdjan (OP-EXT)" userId="S::srdjan.krasic@ext.ec.europa.eu::6da91b18-32dc-43bc-a9cc-2ff6f82cb0e8" providerId="AD" clId="Web-{EF396895-D3C6-4FE9-CA0B-9A5304DD48B9}" dt="2026-06-08T19:48:36.569" v="4" actId="20577"/>
-          <ac:spMkLst>
-            <pc:docMk/>
-            <pc:sldMk cId="1849753633" sldId="1419"/>
-            <ac:spMk id="2" creationId="{0ED33EA1-CB60-0A17-FE41-56415847B7AA}"/>
-          </ac:spMkLst>
-        </pc:spChg>
-      </pc:sldChg>
-      <pc:sldChg chg="modSp">
-        <pc:chgData name="KRASIC Srdjan (OP-EXT)" userId="S::srdjan.krasic@ext.ec.europa.eu::6da91b18-32dc-43bc-a9cc-2ff6f82cb0e8" providerId="AD" clId="Web-{EF396895-D3C6-4FE9-CA0B-9A5304DD48B9}" dt="2026-06-08T19:48:21.052" v="2" actId="14100"/>
-        <pc:sldMkLst>
-          <pc:docMk/>
-          <pc:sldMk cId="1360176188" sldId="1420"/>
-        </pc:sldMkLst>
-        <pc:spChg chg="mod">
-          <ac:chgData name="KRASIC Srdjan (OP-EXT)" userId="S::srdjan.krasic@ext.ec.europa.eu::6da91b18-32dc-43bc-a9cc-2ff6f82cb0e8" providerId="AD" clId="Web-{EF396895-D3C6-4FE9-CA0B-9A5304DD48B9}" dt="2026-06-08T19:48:21.052" v="2" actId="14100"/>
-          <ac:spMkLst>
-            <pc:docMk/>
-            <pc:sldMk cId="1360176188" sldId="1420"/>
-            <ac:spMk id="2" creationId="{557D2D34-DE56-675F-B9BD-085A037D07BA}"/>
-          </ac:spMkLst>
-        </pc:spChg>
-      </pc:sldChg>
-    </pc:docChg>
-  </pc:docChgLst>
-  <pc:docChgLst>
-    <pc:chgData name="KRASIC Srdjan (OP-EXT)" userId="S::srdjan.krasic@ext.ec.europa.eu::6da91b18-32dc-43bc-a9cc-2ff6f82cb0e8" providerId="AD" clId="Web-{D6821814-B061-9325-684D-1513CB072418}"/>
-    <pc:docChg chg="modSld">
-      <pc:chgData name="KRASIC Srdjan (OP-EXT)" userId="S::srdjan.krasic@ext.ec.europa.eu::6da91b18-32dc-43bc-a9cc-2ff6f82cb0e8" providerId="AD" clId="Web-{D6821814-B061-9325-684D-1513CB072418}" dt="2026-06-09T14:48:50.959" v="64" actId="20577"/>
-      <pc:docMkLst>
-        <pc:docMk/>
-      </pc:docMkLst>
-      <pc:sldChg chg="modSp">
-        <pc:chgData name="KRASIC Srdjan (OP-EXT)" userId="S::srdjan.krasic@ext.ec.europa.eu::6da91b18-32dc-43bc-a9cc-2ff6f82cb0e8" providerId="AD" clId="Web-{D6821814-B061-9325-684D-1513CB072418}" dt="2026-06-09T14:41:10.473" v="27" actId="20577"/>
-        <pc:sldMkLst>
-          <pc:docMk/>
-          <pc:sldMk cId="3777327881" sldId="259"/>
-        </pc:sldMkLst>
-        <pc:spChg chg="mod">
-          <ac:chgData name="KRASIC Srdjan (OP-EXT)" userId="S::srdjan.krasic@ext.ec.europa.eu::6da91b18-32dc-43bc-a9cc-2ff6f82cb0e8" providerId="AD" clId="Web-{D6821814-B061-9325-684D-1513CB072418}" dt="2026-06-09T14:41:10.473" v="27" actId="20577"/>
-          <ac:spMkLst>
-            <pc:docMk/>
-            <pc:sldMk cId="3777327881" sldId="259"/>
-            <ac:spMk id="3" creationId="{C76EEE32-05B1-3943-B6B7-F172254DA883}"/>
-          </ac:spMkLst>
-        </pc:spChg>
-        <pc:spChg chg="mod">
-          <ac:chgData name="KRASIC Srdjan (OP-EXT)" userId="S::srdjan.krasic@ext.ec.europa.eu::6da91b18-32dc-43bc-a9cc-2ff6f82cb0e8" providerId="AD" clId="Web-{D6821814-B061-9325-684D-1513CB072418}" dt="2026-06-09T14:37:39.028" v="1" actId="20577"/>
-          <ac:spMkLst>
-            <pc:docMk/>
-            <pc:sldMk cId="3777327881" sldId="259"/>
-            <ac:spMk id="18" creationId="{37F7CF56-95DD-32F5-E7F0-77DDD56B57E1}"/>
-          </ac:spMkLst>
-        </pc:spChg>
-      </pc:sldChg>
-      <pc:sldChg chg="modSp">
-        <pc:chgData name="KRASIC Srdjan (OP-EXT)" userId="S::srdjan.krasic@ext.ec.europa.eu::6da91b18-32dc-43bc-a9cc-2ff6f82cb0e8" providerId="AD" clId="Web-{D6821814-B061-9325-684D-1513CB072418}" dt="2026-06-09T14:48:50.959" v="64" actId="20577"/>
-        <pc:sldMkLst>
-          <pc:docMk/>
-          <pc:sldMk cId="2419242855" sldId="1403"/>
-        </pc:sldMkLst>
-        <pc:spChg chg="mod">
-          <ac:chgData name="KRASIC Srdjan (OP-EXT)" userId="S::srdjan.krasic@ext.ec.europa.eu::6da91b18-32dc-43bc-a9cc-2ff6f82cb0e8" providerId="AD" clId="Web-{D6821814-B061-9325-684D-1513CB072418}" dt="2026-06-09T14:48:50.959" v="64" actId="20577"/>
-          <ac:spMkLst>
-            <pc:docMk/>
-            <pc:sldMk cId="2419242855" sldId="1403"/>
-            <ac:spMk id="3" creationId="{C76EEE32-05B1-3943-B6B7-F172254DA883}"/>
-          </ac:spMkLst>
-        </pc:spChg>
-      </pc:sldChg>
-      <pc:sldChg chg="modSp">
-        <pc:chgData name="KRASIC Srdjan (OP-EXT)" userId="S::srdjan.krasic@ext.ec.europa.eu::6da91b18-32dc-43bc-a9cc-2ff6f82cb0e8" providerId="AD" clId="Web-{D6821814-B061-9325-684D-1513CB072418}" dt="2026-06-09T14:45:08.576" v="29" actId="20577"/>
-        <pc:sldMkLst>
-          <pc:docMk/>
-          <pc:sldMk cId="3700328532" sldId="1408"/>
-        </pc:sldMkLst>
-        <pc:spChg chg="mod">
-          <ac:chgData name="KRASIC Srdjan (OP-EXT)" userId="S::srdjan.krasic@ext.ec.europa.eu::6da91b18-32dc-43bc-a9cc-2ff6f82cb0e8" providerId="AD" clId="Web-{D6821814-B061-9325-684D-1513CB072418}" dt="2026-06-09T14:45:08.576" v="29" actId="20577"/>
-          <ac:spMkLst>
-            <pc:docMk/>
-            <pc:sldMk cId="3700328532" sldId="1408"/>
-            <ac:spMk id="3" creationId="{93CE2629-F9EF-7A93-FD2C-D3730294CEAF}"/>
-          </ac:spMkLst>
-        </pc:spChg>
-      </pc:sldChg>
-    </pc:docChg>
-  </pc:docChgLst>
 </pc:chgInfo>
 </file>
 
@@ -1523,7 +1523,7 @@
           <a:p>
             <a:fld id="{832CBD41-F632-44C2-AFA3-D60AF37912C3}" type="datetime1">
               <a:rPr lang="en-GB" smtClean="0"/>
-              <a:t>09/06/2026</a:t>
+              <a:t>19/06/2026</a:t>
             </a:fld>
             <a:endParaRPr lang="en-IE"/>
           </a:p>
@@ -1701,7 +1701,7 @@
           <a:p>
             <a:fld id="{53E8CA0A-9F26-4807-83A6-34BBB514C621}" type="datetime1">
               <a:rPr lang="en-GB" smtClean="0"/>
-              <a:t>09/06/2026</a:t>
+              <a:t>19/06/2026</a:t>
             </a:fld>
             <a:endParaRPr lang="ca-ES"/>
           </a:p>
@@ -2014,11 +2014,7 @@
           <a:bodyPr/>
           <a:lstStyle/>
           <a:p>
-            <a:r>
-              <a:rPr lang="ca-ES"/>
-              <a:t>Staff changes – introduce Christian, Sevi and Paul</a:t>
-            </a:r>
-            <a:endParaRPr lang="en-US"/>
+            <a:endParaRPr lang="en-US" dirty="0"/>
           </a:p>
         </p:txBody>
       </p:sp>
@@ -2059,6 +2055,98 @@
 </file>
 
 <file path=ppt/notesSlides/notesSlide10.xml><?xml version="1.0" encoding="utf-8"?>
+<p:notes xmlns:a="http://schemas.openxmlformats.org/drawingml/2006/main" xmlns:r="http://schemas.openxmlformats.org/officeDocument/2006/relationships" xmlns:p="http://schemas.openxmlformats.org/presentationml/2006/main">
+  <p:cSld>
+    <p:spTree>
+      <p:nvGrpSpPr>
+        <p:cNvPr id="1" name=""/>
+        <p:cNvGrpSpPr/>
+        <p:nvPr/>
+      </p:nvGrpSpPr>
+      <p:grpSpPr>
+        <a:xfrm>
+          <a:off x="0" y="0"/>
+          <a:ext cx="0" cy="0"/>
+          <a:chOff x="0" y="0"/>
+          <a:chExt cx="0" cy="0"/>
+        </a:xfrm>
+      </p:grpSpPr>
+      <p:sp>
+        <p:nvSpPr>
+          <p:cNvPr id="2" name="Marcador de imagen de diapositiva 1"/>
+          <p:cNvSpPr>
+            <a:spLocks noGrp="1" noRot="1" noChangeAspect="1"/>
+          </p:cNvSpPr>
+          <p:nvPr>
+            <p:ph type="sldImg"/>
+          </p:nvPr>
+        </p:nvSpPr>
+        <p:spPr>
+          <a:xfrm>
+            <a:off x="685800" y="1143000"/>
+            <a:ext cx="5486400" cy="3086100"/>
+          </a:xfrm>
+        </p:spPr>
+      </p:sp>
+      <p:sp>
+        <p:nvSpPr>
+          <p:cNvPr id="3" name="Marcador de notas 2"/>
+          <p:cNvSpPr>
+            <a:spLocks noGrp="1"/>
+          </p:cNvSpPr>
+          <p:nvPr>
+            <p:ph type="body" idx="1"/>
+          </p:nvPr>
+        </p:nvSpPr>
+        <p:spPr/>
+        <p:txBody>
+          <a:bodyPr/>
+          <a:lstStyle/>
+          <a:p>
+            <a:endParaRPr lang="ca-ES" dirty="0">
+              <a:ea typeface="Calibri"/>
+              <a:cs typeface="Calibri"/>
+            </a:endParaRPr>
+          </a:p>
+        </p:txBody>
+      </p:sp>
+      <p:sp>
+        <p:nvSpPr>
+          <p:cNvPr id="4" name="Marcador de número de diapositiva 3"/>
+          <p:cNvSpPr>
+            <a:spLocks noGrp="1"/>
+          </p:cNvSpPr>
+          <p:nvPr>
+            <p:ph type="sldNum" sz="quarter" idx="5"/>
+          </p:nvPr>
+        </p:nvSpPr>
+        <p:spPr/>
+        <p:txBody>
+          <a:bodyPr/>
+          <a:lstStyle/>
+          <a:p>
+            <a:fld id="{2BC7B26A-5688-4821-904C-721F6B6B305D}" type="slidenum">
+              <a:rPr lang="ca-ES" smtClean="0"/>
+              <a:t>12</a:t>
+            </a:fld>
+            <a:endParaRPr lang="ca-ES"/>
+          </a:p>
+        </p:txBody>
+      </p:sp>
+    </p:spTree>
+    <p:extLst>
+      <p:ext uri="{BB962C8B-B14F-4D97-AF65-F5344CB8AC3E}">
+        <p14:creationId xmlns:p14="http://schemas.microsoft.com/office/powerpoint/2010/main" val="800963307"/>
+      </p:ext>
+    </p:extLst>
+  </p:cSld>
+  <p:clrMapOvr>
+    <a:masterClrMapping/>
+  </p:clrMapOvr>
+</p:notes>
+</file>
+
+<file path=ppt/notesSlides/notesSlide11.xml><?xml version="1.0" encoding="utf-8"?>
 <p:notes xmlns:a="http://schemas.openxmlformats.org/drawingml/2006/main" xmlns:r="http://schemas.openxmlformats.org/officeDocument/2006/relationships" xmlns:p="http://schemas.openxmlformats.org/presentationml/2006/main">
   <p:cSld>
     <p:spTree>
@@ -2125,20 +2213,7 @@
           <a:bodyPr/>
           <a:lstStyle/>
           <a:p>
-            <a:r>
-              <a:rPr lang="ca-ES">
-                <a:ea typeface="Calibri"/>
-                <a:cs typeface="Calibri"/>
-              </a:rPr>
-              <a:t>Any questions</a:t>
-            </a:r>
-            <a:endParaRPr lang="en-US"/>
-          </a:p>
-          <a:p>
-            <a:r>
-              <a:rPr lang="ca-ES"/>
-              <a:t>AOB</a:t>
-            </a:r>
+            <a:endParaRPr lang="ca-ES" dirty="0"/>
           </a:p>
         </p:txBody>
       </p:sp>
@@ -2329,11 +2404,7 @@
           <a:bodyPr/>
           <a:lstStyle/>
           <a:p>
-            <a:r>
-              <a:rPr lang="en-GB"/>
-              <a:t>Show each step and explain what information is input on the screen.</a:t>
-            </a:r>
-            <a:endParaRPr lang="en-IE"/>
+            <a:endParaRPr lang="en-IE" dirty="0"/>
           </a:p>
         </p:txBody>
       </p:sp>
@@ -2445,117 +2516,7 @@
                 <a:spcPts val="300"/>
               </a:spcAft>
             </a:pPr>
-            <a:r>
-              <a:rPr lang="en-US" sz="1800">
-                <a:ea typeface="Calibri"/>
-                <a:cs typeface="Calibri"/>
-              </a:rPr>
-              <a:t>As we said in a previous Open User Community meeting, the ESPD-EDM model has moved from Excel to Enterpri</a:t>
-            </a:r>
-            <a:r>
-              <a:rPr lang="en-US" sz="1800">
-                <a:cs typeface="Calibri"/>
-              </a:rPr>
-              <a:t>se</a:t>
-            </a:r>
-            <a:r>
-              <a:rPr lang="en-US" sz="1800">
-                <a:ea typeface="Calibri"/>
-                <a:cs typeface="Calibri"/>
-              </a:rPr>
-              <a:t> Architect. My colleague Srdjan will answer any questions you may have about this.</a:t>
-            </a:r>
-            <a:endParaRPr lang="en-US"/>
-          </a:p>
-          <a:p>
-            <a:pPr algn="just">
-              <a:spcAft>
-                <a:spcPts val="300"/>
-              </a:spcAft>
-            </a:pPr>
-            <a:r>
-              <a:rPr lang="en-US"/>
-              <a:t>The structure of the repositories for ESPD-EDM has been changed, my colleague Sevi will tell you more about that.</a:t>
-            </a:r>
-            <a:endParaRPr lang="en-US">
-              <a:ea typeface="Calibri"/>
-              <a:cs typeface="Calibri"/>
-            </a:endParaRPr>
-          </a:p>
-          <a:p>
-            <a:pPr algn="just">
-              <a:spcAft>
-                <a:spcPts val="300"/>
-              </a:spcAft>
-            </a:pPr>
-            <a:r>
-              <a:rPr lang="en-US" sz="1800">
-                <a:ea typeface="Calibri"/>
-                <a:cs typeface="Calibri"/>
-              </a:rPr>
-              <a:t>The code lists used in ESPD have been updated to align versions with those used in </a:t>
-            </a:r>
-            <a:r>
-              <a:rPr lang="en-US" sz="1800" err="1">
-                <a:ea typeface="Calibri"/>
-                <a:cs typeface="Calibri"/>
-              </a:rPr>
-              <a:t>eForms</a:t>
-            </a:r>
-            <a:endParaRPr lang="en-US" sz="1800">
-              <a:ea typeface="Calibri"/>
-              <a:cs typeface="Calibri"/>
-            </a:endParaRPr>
-          </a:p>
-          <a:p>
-            <a:pPr algn="just">
-              <a:spcAft>
-                <a:spcPts val="300"/>
-              </a:spcAft>
-            </a:pPr>
-            <a:r>
-              <a:rPr lang="en-US" sz="1800">
-                <a:ea typeface="Calibri"/>
-                <a:cs typeface="Calibri"/>
-              </a:rPr>
-              <a:t>The single "criterion" code list has been replaced with two code lists</a:t>
-            </a:r>
-          </a:p>
-          <a:p>
-            <a:pPr algn="just">
-              <a:spcAft>
-                <a:spcPts val="300"/>
-              </a:spcAft>
-            </a:pPr>
-            <a:r>
-              <a:rPr lang="en-US" sz="1800">
-                <a:ea typeface="Calibri"/>
-                <a:cs typeface="Calibri"/>
-              </a:rPr>
-              <a:t>Some changes have been made to improve the generation of validation scripts</a:t>
-            </a:r>
-          </a:p>
-          <a:p>
-            <a:pPr algn="just">
-              <a:spcAft>
-                <a:spcPts val="300"/>
-              </a:spcAft>
-            </a:pPr>
-            <a:r>
-              <a:rPr lang="en-US" sz="1800">
-                <a:ea typeface="Calibri"/>
-                <a:cs typeface="Calibri"/>
-              </a:rPr>
-              <a:t>As we announced last year, the underlying schema has been updated to version 2.4 of UBL</a:t>
-            </a:r>
-          </a:p>
-          <a:p>
-            <a:pPr algn="just">
-              <a:spcAft>
-                <a:spcPts val="300"/>
-              </a:spcAft>
-            </a:pPr>
-            <a:endParaRPr lang="en-US" sz="1800">
+            <a:endParaRPr lang="en-US" sz="1800" dirty="0">
               <a:ea typeface="Calibri"/>
               <a:cs typeface="Calibri"/>
             </a:endParaRPr>
@@ -2648,46 +2609,7 @@
           <a:bodyPr/>
           <a:lstStyle/>
           <a:p>
-            <a:r>
-              <a:rPr lang="en-US">
-                <a:solidFill>
-                  <a:srgbClr val="242424"/>
-                </a:solidFill>
-                <a:highlight>
-                  <a:srgbClr val="FFFFFF"/>
-                </a:highlight>
-              </a:rPr>
-              <a:t>This diagram shows the logical flow of our repositories.</a:t>
-            </a:r>
-            <a:endParaRPr lang="en-US"/>
-          </a:p>
-          <a:p>
-            <a:r>
-              <a:rPr lang="en-US">
-                <a:solidFill>
-                  <a:srgbClr val="242424"/>
-                </a:solidFill>
-                <a:highlight>
-                  <a:srgbClr val="FFFFFF"/>
-                </a:highlight>
-              </a:rPr>
-              <a:t>We start from the conceptual layer, move to supporting tools, and finally reach the implementation layer.</a:t>
-            </a:r>
-            <a:endParaRPr lang="en-US"/>
-          </a:p>
-          <a:p>
-            <a:r>
-              <a:rPr lang="en-US">
-                <a:solidFill>
-                  <a:srgbClr val="242424"/>
-                </a:solidFill>
-                <a:highlight>
-                  <a:srgbClr val="FFFFFF"/>
-                </a:highlight>
-              </a:rPr>
-              <a:t>Each step builds on the previous one, which ensures consistency, reduces duplication, and makes maintenance easier.</a:t>
-            </a:r>
-            <a:endParaRPr lang="en-US"/>
+            <a:endParaRPr lang="en-US" dirty="0"/>
           </a:p>
         </p:txBody>
       </p:sp>
@@ -2728,6 +2650,90 @@
 </file>
 
 <file path=ppt/notesSlides/notesSlide6.xml><?xml version="1.0" encoding="utf-8"?>
+<p:notes xmlns:a="http://schemas.openxmlformats.org/drawingml/2006/main" xmlns:r="http://schemas.openxmlformats.org/officeDocument/2006/relationships" xmlns:p="http://schemas.openxmlformats.org/presentationml/2006/main">
+  <p:cSld>
+    <p:spTree>
+      <p:nvGrpSpPr>
+        <p:cNvPr id="1" name=""/>
+        <p:cNvGrpSpPr/>
+        <p:nvPr/>
+      </p:nvGrpSpPr>
+      <p:grpSpPr>
+        <a:xfrm>
+          <a:off x="0" y="0"/>
+          <a:ext cx="0" cy="0"/>
+          <a:chOff x="0" y="0"/>
+          <a:chExt cx="0" cy="0"/>
+        </a:xfrm>
+      </p:grpSpPr>
+      <p:sp>
+        <p:nvSpPr>
+          <p:cNvPr id="2" name="Slide Image Placeholder 1"/>
+          <p:cNvSpPr>
+            <a:spLocks noGrp="1" noRot="1" noChangeAspect="1"/>
+          </p:cNvSpPr>
+          <p:nvPr>
+            <p:ph type="sldImg"/>
+          </p:nvPr>
+        </p:nvSpPr>
+        <p:spPr/>
+      </p:sp>
+      <p:sp>
+        <p:nvSpPr>
+          <p:cNvPr id="3" name="Notes Placeholder 2"/>
+          <p:cNvSpPr>
+            <a:spLocks noGrp="1"/>
+          </p:cNvSpPr>
+          <p:nvPr>
+            <p:ph type="body" idx="1"/>
+          </p:nvPr>
+        </p:nvSpPr>
+        <p:spPr/>
+        <p:txBody>
+          <a:bodyPr/>
+          <a:lstStyle/>
+          <a:p>
+            <a:endParaRPr lang="en-US" dirty="0"/>
+          </a:p>
+        </p:txBody>
+      </p:sp>
+      <p:sp>
+        <p:nvSpPr>
+          <p:cNvPr id="4" name="Slide Number Placeholder 3"/>
+          <p:cNvSpPr>
+            <a:spLocks noGrp="1"/>
+          </p:cNvSpPr>
+          <p:nvPr>
+            <p:ph type="sldNum" sz="quarter" idx="5"/>
+          </p:nvPr>
+        </p:nvSpPr>
+        <p:spPr/>
+        <p:txBody>
+          <a:bodyPr/>
+          <a:lstStyle/>
+          <a:p>
+            <a:fld id="{2BC7B26A-5688-4821-904C-721F6B6B305D}" type="slidenum">
+              <a:rPr lang="ca-ES" smtClean="0"/>
+              <a:t>8</a:t>
+            </a:fld>
+            <a:endParaRPr lang="ca-ES"/>
+          </a:p>
+        </p:txBody>
+      </p:sp>
+    </p:spTree>
+    <p:extLst>
+      <p:ext uri="{BB962C8B-B14F-4D97-AF65-F5344CB8AC3E}">
+        <p14:creationId xmlns:p14="http://schemas.microsoft.com/office/powerpoint/2010/main" val="4253659492"/>
+      </p:ext>
+    </p:extLst>
+  </p:cSld>
+  <p:clrMapOvr>
+    <a:masterClrMapping/>
+  </p:clrMapOvr>
+</p:notes>
+</file>
+
+<file path=ppt/notesSlides/notesSlide7.xml><?xml version="1.0" encoding="utf-8"?>
 <p:notes xmlns:a="http://schemas.openxmlformats.org/drawingml/2006/main" xmlns:r="http://schemas.openxmlformats.org/officeDocument/2006/relationships" xmlns:p="http://schemas.openxmlformats.org/presentationml/2006/main">
   <p:cSld>
     <p:spTree>
@@ -2794,116 +2800,7 @@
           <a:bodyPr/>
           <a:lstStyle/>
           <a:p>
-            <a:r>
-              <a:rPr lang="en-GB">
-                <a:ea typeface="Calibri"/>
-                <a:cs typeface="Calibri"/>
-              </a:rPr>
-              <a:t>To explain the background to this work:</a:t>
-            </a:r>
-          </a:p>
-          <a:p>
-            <a:r>
-              <a:rPr lang="en-GB">
-                <a:ea typeface="Calibri"/>
-                <a:cs typeface="Calibri"/>
-              </a:rPr>
-              <a:t>We create XSLT files which can be used to validate ESPD Request and ESPD Response forms. These are used in the ITB testbed repository. </a:t>
-            </a:r>
-            <a:endParaRPr lang="en-GB"/>
-          </a:p>
-          <a:p>
-            <a:r>
-              <a:rPr lang="en-GB">
-                <a:ea typeface="Calibri"/>
-                <a:cs typeface="Calibri"/>
-              </a:rPr>
-              <a:t>We generate these XSLT files from </a:t>
-            </a:r>
-            <a:r>
-              <a:rPr lang="en-GB" err="1">
-                <a:ea typeface="Calibri"/>
-                <a:cs typeface="Calibri"/>
-              </a:rPr>
-              <a:t>schematron</a:t>
-            </a:r>
-            <a:r>
-              <a:rPr lang="en-GB">
-                <a:ea typeface="Calibri"/>
-                <a:cs typeface="Calibri"/>
-              </a:rPr>
-              <a:t> files. Some of these </a:t>
-            </a:r>
-            <a:r>
-              <a:rPr lang="en-GB" err="1">
-                <a:ea typeface="Calibri"/>
-                <a:cs typeface="Calibri"/>
-              </a:rPr>
-              <a:t>schematron</a:t>
-            </a:r>
-            <a:r>
-              <a:rPr lang="en-GB">
-                <a:ea typeface="Calibri"/>
-                <a:cs typeface="Calibri"/>
-              </a:rPr>
-              <a:t> files are hand-written, but most are generated from the code list files.</a:t>
-            </a:r>
-          </a:p>
-          <a:p>
-            <a:r>
-              <a:rPr lang="en-GB">
-                <a:ea typeface="Calibri"/>
-                <a:cs typeface="Calibri"/>
-              </a:rPr>
-              <a:t>We keep all of these files in the GitHub repository "</a:t>
-            </a:r>
-            <a:r>
-              <a:rPr lang="en-GB" err="1">
-                <a:ea typeface="Calibri"/>
-                <a:cs typeface="Calibri"/>
-              </a:rPr>
-              <a:t>espd</a:t>
-            </a:r>
-            <a:r>
-              <a:rPr lang="en-GB">
-                <a:ea typeface="Calibri"/>
-                <a:cs typeface="Calibri"/>
-              </a:rPr>
-              <a:t>-validation-</a:t>
-            </a:r>
-            <a:r>
-              <a:rPr lang="en-GB" err="1">
-                <a:ea typeface="Calibri"/>
-                <a:cs typeface="Calibri"/>
-              </a:rPr>
-              <a:t>schematron</a:t>
-            </a:r>
-            <a:r>
-              <a:rPr lang="en-GB">
-                <a:ea typeface="Calibri"/>
-                <a:cs typeface="Calibri"/>
-              </a:rPr>
-              <a:t>". We used a Windows Batch script to run the generation of these files.</a:t>
-            </a:r>
-          </a:p>
-          <a:p>
-            <a:r>
-              <a:rPr lang="en-GB">
-                <a:ea typeface="Calibri"/>
-                <a:cs typeface="Calibri"/>
-              </a:rPr>
-              <a:t>We have created a new version of this script, using the more modern Bash language, which is a variant of Unix.</a:t>
-            </a:r>
-          </a:p>
-          <a:p>
-            <a:r>
-              <a:rPr lang="en-GB">
-                <a:ea typeface="Calibri"/>
-                <a:cs typeface="Calibri"/>
-              </a:rPr>
-              <a:t>This script can be run from a larger variety of computers, and will be easier for us to maintain and update.</a:t>
-            </a:r>
-            <a:endParaRPr lang="en-GB"/>
+            <a:endParaRPr lang="en-GB" dirty="0"/>
           </a:p>
         </p:txBody>
       </p:sp>
@@ -2949,7 +2846,7 @@
 </p:notes>
 </file>
 
-<file path=ppt/notesSlides/notesSlide7.xml><?xml version="1.0" encoding="utf-8"?>
+<file path=ppt/notesSlides/notesSlide8.xml><?xml version="1.0" encoding="utf-8"?>
 <p:notes xmlns:a="http://schemas.openxmlformats.org/drawingml/2006/main" xmlns:r="http://schemas.openxmlformats.org/officeDocument/2006/relationships" xmlns:p="http://schemas.openxmlformats.org/presentationml/2006/main">
   <p:cSld>
     <p:spTree>
@@ -3016,92 +2913,7 @@
           <a:bodyPr/>
           <a:lstStyle/>
           <a:p>
-            <a:r>
-              <a:rPr lang="en-GB"/>
-              <a:t>As I explained in the previous slide, we use </a:t>
-            </a:r>
-            <a:r>
-              <a:rPr lang="en-GB" err="1"/>
-              <a:t>schematron</a:t>
-            </a:r>
-            <a:r>
-              <a:rPr lang="en-GB"/>
-              <a:t> to generate the final XSLT validation scripts. Schematron is a standard XML technology for analysing and validating XML files.</a:t>
-            </a:r>
-          </a:p>
-          <a:p>
-            <a:r>
-              <a:rPr lang="en-GB">
-                <a:ea typeface="Calibri"/>
-                <a:cs typeface="Calibri"/>
-              </a:rPr>
-              <a:t>We have updated these </a:t>
-            </a:r>
-            <a:r>
-              <a:rPr lang="en-GB" err="1">
-                <a:ea typeface="Calibri"/>
-                <a:cs typeface="Calibri"/>
-              </a:rPr>
-              <a:t>schematron</a:t>
-            </a:r>
-            <a:r>
-              <a:rPr lang="en-GB">
-                <a:ea typeface="Calibri"/>
-                <a:cs typeface="Calibri"/>
-              </a:rPr>
-              <a:t> files to use the latest code lists will be included in the version 5.0.0 release of the ESPD-EDM</a:t>
-            </a:r>
-          </a:p>
-          <a:p>
-            <a:r>
-              <a:rPr lang="en-GB">
-                <a:ea typeface="Calibri"/>
-                <a:cs typeface="Calibri"/>
-              </a:rPr>
-              <a:t>We have improved the consistency of the checks included in these </a:t>
-            </a:r>
-            <a:r>
-              <a:rPr lang="en-GB" err="1">
-                <a:ea typeface="Calibri"/>
-                <a:cs typeface="Calibri"/>
-              </a:rPr>
-              <a:t>schematron</a:t>
-            </a:r>
-            <a:r>
-              <a:rPr lang="en-GB">
-                <a:ea typeface="Calibri"/>
-                <a:cs typeface="Calibri"/>
-              </a:rPr>
-              <a:t> files.</a:t>
-            </a:r>
-          </a:p>
-          <a:p>
-            <a:r>
-              <a:rPr lang="en-GB">
-                <a:ea typeface="Calibri"/>
-                <a:cs typeface="Calibri"/>
-              </a:rPr>
-              <a:t>    In the previous version of this repository, there was some variation in the checks for different code lists, for example their version numbers.</a:t>
-            </a:r>
-          </a:p>
-          <a:p>
-            <a:r>
-              <a:rPr lang="en-GB">
-                <a:ea typeface="Calibri"/>
-                <a:cs typeface="Calibri"/>
-              </a:rPr>
-              <a:t>    These checks have been made consistent.</a:t>
-            </a:r>
-          </a:p>
-          <a:p>
-            <a:r>
-              <a:rPr lang="en-GB">
-                <a:ea typeface="Calibri"/>
-                <a:cs typeface="Calibri"/>
-              </a:rPr>
-              <a:t>For those of you who are wondering what the animal is in the schematron logo, it is a mascot called the “Schematroll”, and is a cross between the two marsupials the Bilby and the Bettong.</a:t>
-            </a:r>
-            <a:endParaRPr lang="en-GB"/>
+            <a:endParaRPr lang="en-GB" dirty="0"/>
           </a:p>
         </p:txBody>
       </p:sp>
@@ -3147,7 +2959,7 @@
 </p:notes>
 </file>
 
-<file path=ppt/notesSlides/notesSlide8.xml><?xml version="1.0" encoding="utf-8"?>
+<file path=ppt/notesSlides/notesSlide9.xml><?xml version="1.0" encoding="utf-8"?>
 <p:notes xmlns:a="http://schemas.openxmlformats.org/drawingml/2006/main" xmlns:r="http://schemas.openxmlformats.org/officeDocument/2006/relationships" xmlns:p="http://schemas.openxmlformats.org/presentationml/2006/main">
   <p:cSld>
     <p:spTree>
@@ -3214,75 +3026,10 @@
           <a:bodyPr/>
           <a:lstStyle/>
           <a:p>
-            <a:r>
-              <a:rPr lang="en-GB"/>
-              <a:t>Some of these </a:t>
-            </a:r>
-            <a:r>
-              <a:rPr lang="en-GB" err="1"/>
-              <a:t>schematron</a:t>
-            </a:r>
-            <a:r>
-              <a:rPr lang="en-GB"/>
-              <a:t> files are generated automatically from the code list files. In the future, we plan to generate all of these </a:t>
-            </a:r>
-            <a:r>
-              <a:rPr lang="en-GB" err="1"/>
-              <a:t>schematron</a:t>
-            </a:r>
-            <a:r>
-              <a:rPr lang="en-GB"/>
-              <a:t> files automatically . </a:t>
-            </a:r>
-            <a:endParaRPr lang="en-US">
-              <a:solidFill>
-                <a:srgbClr val="444444"/>
-              </a:solidFill>
+            <a:endParaRPr lang="en-GB" dirty="0">
+              <a:ea typeface="Calibri"/>
+              <a:cs typeface="Calibri"/>
             </a:endParaRPr>
-          </a:p>
-          <a:p>
-            <a:r>
-              <a:rPr lang="en-GB"/>
-              <a:t>We also plan to make improvements to the readability of these files.</a:t>
-            </a:r>
-          </a:p>
-          <a:p>
-            <a:r>
-              <a:rPr lang="en-GB"/>
-              <a:t>We have started preparations for this work.</a:t>
-            </a:r>
-          </a:p>
-          <a:p>
-            <a:r>
-              <a:rPr lang="en-GB">
-                <a:ea typeface="Calibri"/>
-                <a:cs typeface="Calibri"/>
-              </a:rPr>
-              <a:t>We plan to introduce new </a:t>
-            </a:r>
-            <a:r>
-              <a:rPr lang="en-GB" err="1">
-                <a:ea typeface="Calibri"/>
-                <a:cs typeface="Calibri"/>
-              </a:rPr>
-              <a:t>schematron</a:t>
-            </a:r>
-            <a:r>
-              <a:rPr lang="en-GB">
-                <a:ea typeface="Calibri"/>
-                <a:cs typeface="Calibri"/>
-              </a:rPr>
-              <a:t> files to check the order of questions in the ESPD forms. These will be generated automatically from the data model.</a:t>
-            </a:r>
-          </a:p>
-          <a:p>
-            <a:r>
-              <a:rPr lang="en-GB">
-                <a:ea typeface="Calibri"/>
-                <a:cs typeface="Calibri"/>
-              </a:rPr>
-              <a:t>All of these changes will reduce the amount of work we need to do to create a new version of ESPD-EDM</a:t>
-            </a:r>
           </a:p>
         </p:txBody>
       </p:sp>
@@ -3319,98 +3066,6 @@
     <p:extLst>
       <p:ext uri="{BB962C8B-B14F-4D97-AF65-F5344CB8AC3E}">
         <p14:creationId xmlns:p14="http://schemas.microsoft.com/office/powerpoint/2010/main" val="258470615"/>
-      </p:ext>
-    </p:extLst>
-  </p:cSld>
-  <p:clrMapOvr>
-    <a:masterClrMapping/>
-  </p:clrMapOvr>
-</p:notes>
-</file>
-
-<file path=ppt/notesSlides/notesSlide9.xml><?xml version="1.0" encoding="utf-8"?>
-<p:notes xmlns:a="http://schemas.openxmlformats.org/drawingml/2006/main" xmlns:r="http://schemas.openxmlformats.org/officeDocument/2006/relationships" xmlns:p="http://schemas.openxmlformats.org/presentationml/2006/main">
-  <p:cSld>
-    <p:spTree>
-      <p:nvGrpSpPr>
-        <p:cNvPr id="1" name=""/>
-        <p:cNvGrpSpPr/>
-        <p:nvPr/>
-      </p:nvGrpSpPr>
-      <p:grpSpPr>
-        <a:xfrm>
-          <a:off x="0" y="0"/>
-          <a:ext cx="0" cy="0"/>
-          <a:chOff x="0" y="0"/>
-          <a:chExt cx="0" cy="0"/>
-        </a:xfrm>
-      </p:grpSpPr>
-      <p:sp>
-        <p:nvSpPr>
-          <p:cNvPr id="2" name="Marcador de imagen de diapositiva 1"/>
-          <p:cNvSpPr>
-            <a:spLocks noGrp="1" noRot="1" noChangeAspect="1"/>
-          </p:cNvSpPr>
-          <p:nvPr>
-            <p:ph type="sldImg"/>
-          </p:nvPr>
-        </p:nvSpPr>
-        <p:spPr>
-          <a:xfrm>
-            <a:off x="685800" y="1143000"/>
-            <a:ext cx="5486400" cy="3086100"/>
-          </a:xfrm>
-        </p:spPr>
-      </p:sp>
-      <p:sp>
-        <p:nvSpPr>
-          <p:cNvPr id="3" name="Marcador de notas 2"/>
-          <p:cNvSpPr>
-            <a:spLocks noGrp="1"/>
-          </p:cNvSpPr>
-          <p:nvPr>
-            <p:ph type="body" idx="1"/>
-          </p:nvPr>
-        </p:nvSpPr>
-        <p:spPr/>
-        <p:txBody>
-          <a:bodyPr/>
-          <a:lstStyle/>
-          <a:p>
-            <a:endParaRPr lang="ca-ES">
-              <a:ea typeface="Calibri"/>
-              <a:cs typeface="Calibri"/>
-            </a:endParaRPr>
-          </a:p>
-        </p:txBody>
-      </p:sp>
-      <p:sp>
-        <p:nvSpPr>
-          <p:cNvPr id="4" name="Marcador de número de diapositiva 3"/>
-          <p:cNvSpPr>
-            <a:spLocks noGrp="1"/>
-          </p:cNvSpPr>
-          <p:nvPr>
-            <p:ph type="sldNum" sz="quarter" idx="5"/>
-          </p:nvPr>
-        </p:nvSpPr>
-        <p:spPr/>
-        <p:txBody>
-          <a:bodyPr/>
-          <a:lstStyle/>
-          <a:p>
-            <a:fld id="{2BC7B26A-5688-4821-904C-721F6B6B305D}" type="slidenum">
-              <a:rPr lang="ca-ES" smtClean="0"/>
-              <a:t>12</a:t>
-            </a:fld>
-            <a:endParaRPr lang="ca-ES"/>
-          </a:p>
-        </p:txBody>
-      </p:sp>
-    </p:spTree>
-    <p:extLst>
-      <p:ext uri="{BB962C8B-B14F-4D97-AF65-F5344CB8AC3E}">
-        <p14:creationId xmlns:p14="http://schemas.microsoft.com/office/powerpoint/2010/main" val="800963307"/>
       </p:ext>
     </p:extLst>
   </p:cSld>
@@ -3426,11 +3081,11 @@
     <p:bg>
       <p:bgPr>
         <a:blipFill dpi="0" rotWithShape="1">
-          <a:blip>
+          <a:blip r:embed="rId2">
             <a:lum/>
             <a:extLst>
               <a:ext uri="{96DAC541-7B7A-43D3-8B79-37D633B846F1}">
-                <asvg:svgBlip xmlns:asvg="http://schemas.microsoft.com/office/drawing/2016/SVG/main" r:embed="rId2"/>
+                <asvg:svgBlip xmlns:asvg="http://schemas.microsoft.com/office/drawing/2016/SVG/main" r:embed="rId3"/>
               </a:ext>
             </a:extLst>
           </a:blip>
@@ -3945,7 +3600,7 @@
           <a:p>
             <a:fld id="{AB5D84A9-B6D7-4ECF-A16E-8BD4B8A45A99}" type="datetime1">
               <a:rPr lang="LID4096" smtClean="0"/>
-              <a:t>06/09/2026</a:t>
+              <a:t>06/19/2026</a:t>
             </a:fld>
             <a:endParaRPr lang="en-LU"/>
           </a:p>
@@ -4024,11 +3679,11 @@
     <p:bg>
       <p:bgPr>
         <a:blipFill dpi="0" rotWithShape="1">
-          <a:blip>
+          <a:blip r:embed="rId2">
             <a:lum/>
             <a:extLst>
               <a:ext uri="{96DAC541-7B7A-43D3-8B79-37D633B846F1}">
-                <asvg:svgBlip xmlns:asvg="http://schemas.microsoft.com/office/drawing/2016/SVG/main" r:embed="rId2"/>
+                <asvg:svgBlip xmlns:asvg="http://schemas.microsoft.com/office/drawing/2016/SVG/main" r:embed="rId3"/>
               </a:ext>
             </a:extLst>
           </a:blip>
@@ -5677,13 +5332,13 @@
           <p:nvPr userDrawn="1"/>
         </p:nvPicPr>
         <p:blipFill>
-          <a:blip>
+          <a:blip r:embed="rId2">
             <a:extLst>
               <a:ext uri="{28A0092B-C50C-407E-A947-70E740481C1C}">
                 <a14:useLocalDpi xmlns:a14="http://schemas.microsoft.com/office/drawing/2010/main" val="0"/>
               </a:ext>
               <a:ext uri="{96DAC541-7B7A-43D3-8B79-37D633B846F1}">
-                <asvg:svgBlip xmlns:asvg="http://schemas.microsoft.com/office/drawing/2016/SVG/main" r:embed="rId2"/>
+                <asvg:svgBlip xmlns:asvg="http://schemas.microsoft.com/office/drawing/2016/SVG/main" r:embed="rId3"/>
               </a:ext>
             </a:extLst>
           </a:blip>
@@ -5746,13 +5401,13 @@
           <p:nvPr userDrawn="1"/>
         </p:nvPicPr>
         <p:blipFill>
-          <a:blip>
+          <a:blip r:embed="rId2">
             <a:extLst>
               <a:ext uri="{28A0092B-C50C-407E-A947-70E740481C1C}">
                 <a14:useLocalDpi xmlns:a14="http://schemas.microsoft.com/office/drawing/2010/main" val="0"/>
               </a:ext>
               <a:ext uri="{96DAC541-7B7A-43D3-8B79-37D633B846F1}">
-                <asvg:svgBlip xmlns:asvg="http://schemas.microsoft.com/office/drawing/2016/SVG/main" r:embed="rId2"/>
+                <asvg:svgBlip xmlns:asvg="http://schemas.microsoft.com/office/drawing/2016/SVG/main" r:embed="rId3"/>
               </a:ext>
             </a:extLst>
           </a:blip>
@@ -5785,13 +5440,13 @@
           <p:nvPr userDrawn="1"/>
         </p:nvPicPr>
         <p:blipFill rotWithShape="1">
-          <a:blip>
+          <a:blip r:embed="rId4">
             <a:extLst>
               <a:ext uri="{28A0092B-C50C-407E-A947-70E740481C1C}">
                 <a14:useLocalDpi xmlns:a14="http://schemas.microsoft.com/office/drawing/2010/main" val="0"/>
               </a:ext>
               <a:ext uri="{96DAC541-7B7A-43D3-8B79-37D633B846F1}">
-                <asvg:svgBlip xmlns:asvg="http://schemas.microsoft.com/office/drawing/2016/SVG/main" r:embed="rId3"/>
+                <asvg:svgBlip xmlns:asvg="http://schemas.microsoft.com/office/drawing/2016/SVG/main" r:embed="rId5"/>
               </a:ext>
             </a:extLst>
           </a:blip>
@@ -5823,13 +5478,13 @@
           <p:nvPr userDrawn="1"/>
         </p:nvPicPr>
         <p:blipFill rotWithShape="1">
-          <a:blip>
+          <a:blip r:embed="rId4">
             <a:extLst>
               <a:ext uri="{28A0092B-C50C-407E-A947-70E740481C1C}">
                 <a14:useLocalDpi xmlns:a14="http://schemas.microsoft.com/office/drawing/2010/main" val="0"/>
               </a:ext>
               <a:ext uri="{96DAC541-7B7A-43D3-8B79-37D633B846F1}">
-                <asvg:svgBlip xmlns:asvg="http://schemas.microsoft.com/office/drawing/2016/SVG/main" r:embed="rId3"/>
+                <asvg:svgBlip xmlns:asvg="http://schemas.microsoft.com/office/drawing/2016/SVG/main" r:embed="rId5"/>
               </a:ext>
             </a:extLst>
           </a:blip>
@@ -5861,13 +5516,13 @@
           <p:nvPr userDrawn="1"/>
         </p:nvPicPr>
         <p:blipFill rotWithShape="1">
-          <a:blip>
+          <a:blip r:embed="rId6">
             <a:extLst>
               <a:ext uri="{28A0092B-C50C-407E-A947-70E740481C1C}">
                 <a14:useLocalDpi xmlns:a14="http://schemas.microsoft.com/office/drawing/2010/main" val="0"/>
               </a:ext>
               <a:ext uri="{96DAC541-7B7A-43D3-8B79-37D633B846F1}">
-                <asvg:svgBlip xmlns:asvg="http://schemas.microsoft.com/office/drawing/2016/SVG/main" r:embed="rId4"/>
+                <asvg:svgBlip xmlns:asvg="http://schemas.microsoft.com/office/drawing/2016/SVG/main" r:embed="rId7"/>
               </a:ext>
             </a:extLst>
           </a:blip>
@@ -6503,13 +6158,13 @@
           <p:nvPr userDrawn="1"/>
         </p:nvPicPr>
         <p:blipFill>
-          <a:blip>
+          <a:blip r:embed="rId2">
             <a:extLst>
               <a:ext uri="{28A0092B-C50C-407E-A947-70E740481C1C}">
                 <a14:useLocalDpi xmlns:a14="http://schemas.microsoft.com/office/drawing/2010/main" val="0"/>
               </a:ext>
               <a:ext uri="{96DAC541-7B7A-43D3-8B79-37D633B846F1}">
-                <asvg:svgBlip xmlns:asvg="http://schemas.microsoft.com/office/drawing/2016/SVG/main" r:embed="rId2"/>
+                <asvg:svgBlip xmlns:asvg="http://schemas.microsoft.com/office/drawing/2016/SVG/main" r:embed="rId3"/>
               </a:ext>
             </a:extLst>
           </a:blip>
@@ -6585,13 +6240,13 @@
           <p:nvPr userDrawn="1"/>
         </p:nvPicPr>
         <p:blipFill>
-          <a:blip>
+          <a:blip r:embed="rId4">
             <a:extLst>
               <a:ext uri="{28A0092B-C50C-407E-A947-70E740481C1C}">
                 <a14:useLocalDpi xmlns:a14="http://schemas.microsoft.com/office/drawing/2010/main" val="0"/>
               </a:ext>
               <a:ext uri="{96DAC541-7B7A-43D3-8B79-37D633B846F1}">
-                <asvg:svgBlip xmlns:asvg="http://schemas.microsoft.com/office/drawing/2016/SVG/main" r:embed="rId3"/>
+                <asvg:svgBlip xmlns:asvg="http://schemas.microsoft.com/office/drawing/2016/SVG/main" r:embed="rId5"/>
               </a:ext>
             </a:extLst>
           </a:blip>
@@ -6628,11 +6283,11 @@
     <p:bg>
       <p:bgPr>
         <a:blipFill dpi="0" rotWithShape="1">
-          <a:blip>
+          <a:blip r:embed="rId2">
             <a:lum/>
             <a:extLst>
               <a:ext uri="{96DAC541-7B7A-43D3-8B79-37D633B846F1}">
-                <asvg:svgBlip xmlns:asvg="http://schemas.microsoft.com/office/drawing/2016/SVG/main" r:embed="rId2"/>
+                <asvg:svgBlip xmlns:asvg="http://schemas.microsoft.com/office/drawing/2016/SVG/main" r:embed="rId3"/>
               </a:ext>
             </a:extLst>
           </a:blip>
@@ -8409,7 +8064,7 @@
           <a:p>
             <a:fld id="{99C4F5CC-0853-4A72-99B5-57A19FFF8770}" type="datetime1">
               <a:rPr lang="LID4096" smtClean="0"/>
-              <a:t>06/09/2026</a:t>
+              <a:t>06/19/2026</a:t>
             </a:fld>
             <a:endParaRPr lang="en-LU"/>
           </a:p>
@@ -8746,7 +8401,7 @@
           <a:p>
             <a:fld id="{6520AC0C-D4E7-44CC-B70C-8605488E2BB0}" type="datetime1">
               <a:rPr lang="LID4096" smtClean="0"/>
-              <a:t>06/09/2026</a:t>
+              <a:t>06/19/2026</a:t>
             </a:fld>
             <a:endParaRPr lang="en-LU"/>
           </a:p>
@@ -8956,7 +8611,7 @@
           <a:p>
             <a:fld id="{384F1A5A-B293-455A-A4D7-07A0AE3FF677}" type="datetime1">
               <a:rPr lang="LID4096" smtClean="0"/>
-              <a:t>06/09/2026</a:t>
+              <a:t>06/19/2026</a:t>
             </a:fld>
             <a:endParaRPr lang="en-LU"/>
           </a:p>
@@ -9285,7 +8940,7 @@
           <a:p>
             <a:fld id="{522BBC41-FE8B-449D-A674-6C450A80ED70}" type="datetime1">
               <a:rPr lang="LID4096" smtClean="0"/>
-              <a:t>06/09/2026</a:t>
+              <a:t>06/19/2026</a:t>
             </a:fld>
             <a:endParaRPr lang="en-LU"/>
           </a:p>
@@ -9656,7 +9311,7 @@
           <a:p>
             <a:fld id="{C71A1885-F2BA-4786-98E4-677E39FA53D5}" type="datetime1">
               <a:rPr lang="LID4096" smtClean="0"/>
-              <a:t>06/09/2026</a:t>
+              <a:t>06/19/2026</a:t>
             </a:fld>
             <a:endParaRPr lang="en-LU"/>
           </a:p>
@@ -10110,7 +9765,7 @@
           <a:p>
             <a:fld id="{615EFA2B-1A1A-4501-8DD4-3C73C598CDF1}" type="datetime1">
               <a:rPr lang="LID4096" smtClean="0"/>
-              <a:t>06/09/2026</a:t>
+              <a:t>06/19/2026</a:t>
             </a:fld>
             <a:endParaRPr lang="en-LU"/>
           </a:p>
@@ -10341,11 +9996,11 @@
     <p:bg>
       <p:bgPr>
         <a:blipFill dpi="0" rotWithShape="1">
-          <a:blip>
+          <a:blip r:embed="rId2">
             <a:lum/>
             <a:extLst>
               <a:ext uri="{96DAC541-7B7A-43D3-8B79-37D633B846F1}">
-                <asvg:svgBlip xmlns:asvg="http://schemas.microsoft.com/office/drawing/2016/SVG/main" r:embed="rId2"/>
+                <asvg:svgBlip xmlns:asvg="http://schemas.microsoft.com/office/drawing/2016/SVG/main" r:embed="rId3"/>
               </a:ext>
             </a:extLst>
           </a:blip>
@@ -10491,7 +10146,7 @@
           <a:p>
             <a:fld id="{59ED3981-F1EE-4EFF-8709-8EA0FC11C3EC}" type="datetime1">
               <a:rPr lang="LID4096" smtClean="0"/>
-              <a:t>06/09/2026</a:t>
+              <a:t>06/19/2026</a:t>
             </a:fld>
             <a:endParaRPr lang="en-LU"/>
           </a:p>
@@ -10722,11 +10377,11 @@
     <p:bg>
       <p:bgPr>
         <a:blipFill dpi="0" rotWithShape="1">
-          <a:blip>
+          <a:blip r:embed="rId17">
             <a:lum/>
             <a:extLst>
               <a:ext uri="{96DAC541-7B7A-43D3-8B79-37D633B846F1}">
-                <asvg:svgBlip xmlns:asvg="http://schemas.microsoft.com/office/drawing/2016/SVG/main" r:embed="rId17"/>
+                <asvg:svgBlip xmlns:asvg="http://schemas.microsoft.com/office/drawing/2016/SVG/main" r:embed="rId18"/>
               </a:ext>
             </a:extLst>
           </a:blip>
@@ -10898,7 +10553,7 @@
           <a:p>
             <a:fld id="{99D93193-BD63-462C-943D-5686CE586CE0}" type="datetime1">
               <a:rPr lang="LID4096" smtClean="0"/>
-              <a:t>06/09/2026</a:t>
+              <a:t>06/19/2026</a:t>
             </a:fld>
             <a:endParaRPr lang="en-LU"/>
           </a:p>
@@ -11337,13 +10992,13 @@
           <p:nvPr userDrawn="1"/>
         </p:nvPicPr>
         <p:blipFill>
-          <a:blip>
+          <a:blip r:embed="rId12">
             <a:extLst>
               <a:ext uri="{28A0092B-C50C-407E-A947-70E740481C1C}">
                 <a14:useLocalDpi xmlns:a14="http://schemas.microsoft.com/office/drawing/2010/main" val="0"/>
               </a:ext>
               <a:ext uri="{96DAC541-7B7A-43D3-8B79-37D633B846F1}">
-                <asvg:svgBlip xmlns:asvg="http://schemas.microsoft.com/office/drawing/2016/SVG/main" r:embed="rId12"/>
+                <asvg:svgBlip xmlns:asvg="http://schemas.microsoft.com/office/drawing/2016/SVG/main" r:embed="rId13"/>
               </a:ext>
             </a:extLst>
           </a:blip>
@@ -11508,7 +11163,7 @@
             <a:fld id="{AE753531-74F9-46DB-8226-2C37E7D3FBBB}" type="datetime3">
               <a:rPr lang="nl-BE" smtClean="0"/>
               <a:pPr/>
-              <a:t>9.06.26</a:t>
+              <a:t>19.06.26</a:t>
             </a:fld>
             <a:endParaRPr lang="nl-BE"/>
           </a:p>
@@ -16176,7 +15831,7 @@
               <a:rPr lang="en-US" sz="2400" err="1">
                 <a:ea typeface="Calibri"/>
                 <a:cs typeface="Calibri"/>
-                <a:hlinkClick r:id="rId2"/>
+                <a:hlinkClick r:id="rId3"/>
               </a:rPr>
               <a:t>espd</a:t>
             </a:r>
@@ -16184,7 +15839,7 @@
               <a:rPr lang="en-US" sz="2400">
                 <a:ea typeface="Calibri"/>
                 <a:cs typeface="Calibri"/>
-                <a:hlinkClick r:id="rId2"/>
+                <a:hlinkClick r:id="rId3"/>
               </a:rPr>
               <a:t>-conceptual-model</a:t>
             </a:r>
@@ -16227,7 +15882,7 @@
               <a:rPr lang="en-US" sz="2400" err="1">
                 <a:ea typeface="Calibri"/>
                 <a:cs typeface="Calibri"/>
-                <a:hlinkClick r:id="rId3"/>
+                <a:hlinkClick r:id="rId4"/>
               </a:rPr>
               <a:t>espd</a:t>
             </a:r>
@@ -16235,7 +15890,7 @@
               <a:rPr lang="en-US" sz="2400">
                 <a:ea typeface="Calibri"/>
                 <a:cs typeface="Calibri"/>
-                <a:hlinkClick r:id="rId3"/>
+                <a:hlinkClick r:id="rId4"/>
               </a:rPr>
               <a:t>-tools</a:t>
             </a:r>
@@ -16278,7 +15933,7 @@
               <a:rPr lang="en-US" sz="2400">
                 <a:ea typeface="Calibri"/>
                 <a:cs typeface="Calibri"/>
-                <a:hlinkClick r:id="rId4"/>
+                <a:hlinkClick r:id="rId5"/>
               </a:rPr>
               <a:t>ESPD-EDM</a:t>
             </a:r>
@@ -17981,15 +17636,6 @@
 </file>
 
 <file path=customXml/item2.xml><?xml version="1.0" encoding="utf-8"?>
-<?mso-contentType ?>
-<FormTemplates xmlns="http://schemas.microsoft.com/sharepoint/v3/contenttype/forms">
-  <Display>DocumentLibraryForm</Display>
-  <Edit>DocumentLibraryForm</Edit>
-  <New>DocumentLibraryForm</New>
-</FormTemplates>
-</file>
-
-<file path=customXml/item3.xml><?xml version="1.0" encoding="utf-8"?>
 <p:properties xmlns:p="http://schemas.microsoft.com/office/2006/metadata/properties" xmlns:xsi="http://www.w3.org/2001/XMLSchema-instance" xmlns:pc="http://schemas.microsoft.com/office/infopath/2007/PartnerControls">
   <documentManagement>
     <lcf76f155ced4ddcb4097134ff3c332f xmlns="541a8a8b-b856-4d35-a5c7-7f2c0ec3d499">
@@ -17998,6 +17644,15 @@
     <TaxCatchAll xmlns="e0757b53-df10-4b98-9811-094c4c3e23a8" xsi:nil="true"/>
   </documentManagement>
 </p:properties>
+</file>
+
+<file path=customXml/item3.xml><?xml version="1.0" encoding="utf-8"?>
+<?mso-contentType ?>
+<FormTemplates xmlns="http://schemas.microsoft.com/sharepoint/v3/contenttype/forms">
+  <Display>DocumentLibraryForm</Display>
+  <Edit>DocumentLibraryForm</Edit>
+  <New>DocumentLibraryForm</New>
+</FormTemplates>
 </file>
 
 <file path=customXml/itemProps1.xml><?xml version="1.0" encoding="utf-8"?>
@@ -18020,14 +17675,6 @@
 </file>
 
 <file path=customXml/itemProps2.xml><?xml version="1.0" encoding="utf-8"?>
-<ds:datastoreItem xmlns:ds="http://schemas.openxmlformats.org/officeDocument/2006/customXml" ds:itemID="{50A0C835-9C17-4D55-BA6A-FA95BDCCF4BC}">
-  <ds:schemaRefs>
-    <ds:schemaRef ds:uri="http://schemas.microsoft.com/sharepoint/v3/contenttype/forms"/>
-  </ds:schemaRefs>
-</ds:datastoreItem>
-</file>
-
-<file path=customXml/itemProps3.xml><?xml version="1.0" encoding="utf-8"?>
 <ds:datastoreItem xmlns:ds="http://schemas.openxmlformats.org/officeDocument/2006/customXml" ds:itemID="{8CF5F66E-14E4-4810-B0A6-0920C2F66A8F}">
   <ds:schemaRefs>
     <ds:schemaRef ds:uri="541a8a8b-b856-4d35-a5c7-7f2c0ec3d499"/>
@@ -18042,4 +17689,12 @@
     <ds:schemaRef ds:uri="http://www.w3.org/XML/1998/namespace"/>
   </ds:schemaRefs>
 </ds:datastoreItem>
+</file>
+
+<file path=customXml/itemProps3.xml><?xml version="1.0" encoding="utf-8"?>
+<ds:datastoreItem xmlns:ds="http://schemas.openxmlformats.org/officeDocument/2006/customXml" ds:itemID="{50A0C835-9C17-4D55-BA6A-FA95BDCCF4BC}">
+  <ds:schemaRefs>
+    <ds:schemaRef ds:uri="http://schemas.microsoft.com/sharepoint/v3/contenttype/forms"/>
+  </ds:schemaRefs>
+</ds:datastoreItem>
 </file>
</xml_diff>